<commit_message>
Add live Fireworks extraction with reviewed PDF provenance
</commit_message>
<xml_diff>
--- a/docs/RecallScope-Pitch.pptx
+++ b/docs/RecallScope-Pitch.pptx
@@ -2,20 +2,20 @@
 <file path=ppt/presentation.xml><?xml version="1.0" encoding="utf-8"?>
 <p:presentation xmlns:p="http://schemas.openxmlformats.org/presentationml/2006/main">
   <p:sldMasterIdLst>
-    <p:sldMasterId xmlns:r="http://schemas.openxmlformats.org/officeDocument/2006/relationships" id="2147483648" r:id="R910a4e19d4ea412d"/>
+    <p:sldMasterId xmlns:r="http://schemas.openxmlformats.org/officeDocument/2006/relationships" id="2147483648" r:id="R34855c77032d4f91"/>
   </p:sldMasterIdLst>
   <p:notesMasterIdLst>
-    <p:notesMasterId xmlns:r="http://schemas.openxmlformats.org/officeDocument/2006/relationships" r:id="Rd3d93ec8b73f4238"/>
+    <p:notesMasterId xmlns:r="http://schemas.openxmlformats.org/officeDocument/2006/relationships" r:id="R594c1cdbb043402b"/>
   </p:notesMasterIdLst>
   <p:sldIdLst>
-    <p:sldId xmlns:r="http://schemas.openxmlformats.org/officeDocument/2006/relationships" id="256" r:id="R03c77c8a6c764db0"/>
-    <p:sldId xmlns:r="http://schemas.openxmlformats.org/officeDocument/2006/relationships" id="257" r:id="R9b18b3ee5e8946db"/>
-    <p:sldId xmlns:r="http://schemas.openxmlformats.org/officeDocument/2006/relationships" id="258" r:id="R18fb8b8fabf742b1"/>
-    <p:sldId xmlns:r="http://schemas.openxmlformats.org/officeDocument/2006/relationships" id="259" r:id="R77330a7a43604bce"/>
-    <p:sldId xmlns:r="http://schemas.openxmlformats.org/officeDocument/2006/relationships" id="260" r:id="R4a9b8d242bef40a7"/>
-    <p:sldId xmlns:r="http://schemas.openxmlformats.org/officeDocument/2006/relationships" id="261" r:id="R495d9e9bc32c4ea0"/>
-    <p:sldId xmlns:r="http://schemas.openxmlformats.org/officeDocument/2006/relationships" id="262" r:id="R3d7df633d9064536"/>
-    <p:sldId xmlns:r="http://schemas.openxmlformats.org/officeDocument/2006/relationships" id="263" r:id="Rcbfb60383568445c"/>
+    <p:sldId xmlns:r="http://schemas.openxmlformats.org/officeDocument/2006/relationships" id="256" r:id="R9b05f7be196f4a67"/>
+    <p:sldId xmlns:r="http://schemas.openxmlformats.org/officeDocument/2006/relationships" id="257" r:id="Re4e841a156fd4b94"/>
+    <p:sldId xmlns:r="http://schemas.openxmlformats.org/officeDocument/2006/relationships" id="258" r:id="R66f835e6567f4899"/>
+    <p:sldId xmlns:r="http://schemas.openxmlformats.org/officeDocument/2006/relationships" id="259" r:id="R6b1da41125884173"/>
+    <p:sldId xmlns:r="http://schemas.openxmlformats.org/officeDocument/2006/relationships" id="260" r:id="R8ee3c07e1fa44dfd"/>
+    <p:sldId xmlns:r="http://schemas.openxmlformats.org/officeDocument/2006/relationships" id="261" r:id="R08203ca6ae0e406b"/>
+    <p:sldId xmlns:r="http://schemas.openxmlformats.org/officeDocument/2006/relationships" id="262" r:id="R8f2f575a7989444d"/>
+    <p:sldId xmlns:r="http://schemas.openxmlformats.org/officeDocument/2006/relationships" id="263" r:id="R8180b45f837846ca"/>
   </p:sldIdLst>
   <p:sldSz cx="12192000" cy="6858000"/>
   <p:notesSz cx="6858000" cy="9144000"/>
@@ -589,7 +589,7 @@
           <a:lstStyle xmlns:a="http://schemas.openxmlformats.org/drawingml/2006/main"/>
           <a:p xmlns:a="http://schemas.openxmlformats.org/drawingml/2006/main">
             <a:r>
-              <a:t>This workflow is the intended demo story. Keep the final presentation aligned with functionality that the product team has actually verified. Synthetic fixture data underpins the numbers shown on slide 4.</a:t>
+              <a:t>The local workflow stores uploaded source files, proposes extracted records for operator review, and calculates trace results from accepted relationships. Fireworks text and single-page PDF extraction checks have passed on labelled synthetic fixtures. The PDF path rasterizes pages before sending the resulting images to the configured model. Original PDFs, AI page images, provider/model identity and SHA-256 hashes remain available as provenance. The pre-authored demonstration on slide 4 is separate from the live fixture result shown on slide 5.</a:t>
             </a:r>
           </a:p>
         </p:txBody>
@@ -729,7 +729,7 @@
           <a:lstStyle xmlns:a="http://schemas.openxmlformats.org/drawingml/2006/main"/>
           <a:p xmlns:a="http://schemas.openxmlformats.org/drawingml/2006/main">
             <a:r>
-              <a:t>Architecture and build state supplied by the implementation lead. The live AI key has not been configured. Do not claim live AI validation, extraction accuracy or production readiness. Deterministic code computes trace results from reviewed record relationships. The operator retains responsibility for reviewing evidence and unresolved links. Product decisions should preserve unknown states rather than silently treating them as clean results.</a:t>
+              <a:t>Verified facts supplied by the RecallScope implementation lead: Fireworks API authentication succeeded. A real text extraction returned three correct records, including 180 delivered packs. A real single-page PDF was rasterized into a page image and sent to Fireworks model accounts/fireworks/models/kimi-k2p6. It returned three correct records. The operator reviewed and approved the import, producing 180 confirmed packs and zero unresolved packs. The application retained the original PDF, AI page images, provider/model identity and SHA-256 hashes. These are observed results on small labelled synthetic fixtures, not a general accuracy estimate, speed claim or real manufacturer validation. The OpenAI option remains available, but live OpenAI extraction is untested. Deterministic code computes trace totals from reviewed relationships. The operator remains responsible for evidence review and resolving unknown links.</a:t>
             </a:r>
           </a:p>
         </p:txBody>
@@ -869,7 +869,7 @@
           <a:lstStyle xmlns:a="http://schemas.openxmlformats.org/drawingml/2006/main"/>
           <a:p xmlns:a="http://schemas.openxmlformats.org/drawingml/2006/main">
             <a:r>
-              <a:t>This is a proposed validation plan, not completed research. Use permissioned and appropriately handled manufacturer records. Establish a human-reviewed expected trace before comparing outputs. Measure completion time without promising any reduction. FDA June 2026 tabletop exercise update says proactive supply-chain coordination drove the strongest results more than any particular technology: https://www.fda.gov/food/hfp-constituent-updates/fda-releases-report-traceability-readiness-tabletop-exercises-and-updated-faqs . This supports explicitly examining information gaps and handoffs rather than claiming that software alone resolves traceability.</a:t>
+              <a:t>This is a proposed validation plan, not completed research. Use permissioned and appropriately handled manufacturer records. Establish a human-reviewed expected trace before comparing outputs. Measure completion time without promising any reduction. FDA June 2026 tabletop exercise update says proactive supply-chain coordination drove the strongest results more than any particular technology: https://www.fda.gov/food/hfp-constituent-updates/fda-releases-report-traceability-readiness-tabletop-exercises-and-updated-faqs . This supports explicitly examining information gaps and handoffs rather than claiming that software alone resolves traceability. Live Fireworks extraction checks have passed on small synthetic text and PDF fixtures. That result does not replace the proposed manufacturer pilot. Public deployment, the final demo video and GitHub push remain pending. No exact automated-test count is asserted in this deck.</a:t>
             </a:r>
           </a:p>
         </p:txBody>
@@ -1007,7 +1007,7 @@
   </p:cSld>
   <p:clrMap bg1="lt1" tx1="dk1" bg2="lt2" tx2="dk2" accent1="accent1" accent2="accent2" accent3="accent3" accent4="accent4" accent5="accent5" accent6="accent6" hlink="hlink" folHlink="folHlink"/>
   <p:sldLayoutIdLst>
-    <p:sldLayoutId xmlns:r="http://schemas.openxmlformats.org/officeDocument/2006/relationships" id="2147483649" r:id="R93b1881b42704eb4"/>
+    <p:sldLayoutId xmlns:r="http://schemas.openxmlformats.org/officeDocument/2006/relationships" id="2147483649" r:id="Re6c9437af1334bc1"/>
   </p:sldLayoutIdLst>
   <p:txStyles>
     <p:titleStyle>
@@ -1587,6 +1587,7 @@
           <a:lstStyle xmlns:a="http://schemas.openxmlformats.org/drawingml/2006/main"/>
           <a:p xmlns:a="http://schemas.openxmlformats.org/drawingml/2006/main">
             <a:pPr algn="l">
+              <a:buNone/>
               <a:defRPr sz="6900" b="1">
                 <a:solidFill>
                   <a:srgbClr val="FFFFFF"/>
@@ -1644,6 +1645,7 @@
           <a:lstStyle xmlns:a="http://schemas.openxmlformats.org/drawingml/2006/main"/>
           <a:p xmlns:a="http://schemas.openxmlformats.org/drawingml/2006/main">
             <a:pPr algn="l">
+              <a:buNone/>
               <a:defRPr sz="3450" b="0">
                 <a:solidFill>
                   <a:srgbClr val="9CDED0"/>
@@ -1701,6 +1703,7 @@
           <a:lstStyle xmlns:a="http://schemas.openxmlformats.org/drawingml/2006/main"/>
           <a:p xmlns:a="http://schemas.openxmlformats.org/drawingml/2006/main">
             <a:pPr algn="l">
+              <a:buNone/>
               <a:defRPr sz="2250" b="0">
                 <a:solidFill>
                   <a:srgbClr val="FFFFFF"/>
@@ -1758,6 +1761,7 @@
           <a:lstStyle xmlns:a="http://schemas.openxmlformats.org/drawingml/2006/main"/>
           <a:p xmlns:a="http://schemas.openxmlformats.org/drawingml/2006/main">
             <a:pPr algn="l">
+              <a:buNone/>
               <a:defRPr sz="1575" b="0">
                 <a:solidFill>
                   <a:srgbClr val="9CDED0"/>
@@ -1815,6 +1819,7 @@
           <a:lstStyle xmlns:a="http://schemas.openxmlformats.org/drawingml/2006/main"/>
           <a:p xmlns:a="http://schemas.openxmlformats.org/drawingml/2006/main">
             <a:pPr algn="r">
+              <a:buNone/>
               <a:defRPr sz="1575" b="0">
                 <a:solidFill>
                   <a:srgbClr val="9CDED0"/>
@@ -1901,6 +1906,7 @@
           <a:lstStyle xmlns:a="http://schemas.openxmlformats.org/drawingml/2006/main"/>
           <a:p xmlns:a="http://schemas.openxmlformats.org/drawingml/2006/main">
             <a:pPr algn="l">
+              <a:buNone/>
               <a:defRPr sz="3600" b="1">
                 <a:solidFill>
                   <a:srgbClr val="16323F"/>
@@ -1958,6 +1964,7 @@
           <a:lstStyle xmlns:a="http://schemas.openxmlformats.org/drawingml/2006/main"/>
           <a:p xmlns:a="http://schemas.openxmlformats.org/drawingml/2006/main">
             <a:pPr algn="l">
+              <a:buNone/>
               <a:defRPr sz="1275" b="0">
                 <a:solidFill>
                   <a:srgbClr val="58717A"/>
@@ -2015,6 +2022,7 @@
           <a:lstStyle xmlns:a="http://schemas.openxmlformats.org/drawingml/2006/main"/>
           <a:p xmlns:a="http://schemas.openxmlformats.org/drawingml/2006/main">
             <a:pPr algn="r">
+              <a:buNone/>
               <a:defRPr sz="1275" b="0">
                 <a:solidFill>
                   <a:srgbClr val="58717A"/>
@@ -2072,6 +2080,7 @@
           <a:lstStyle xmlns:a="http://schemas.openxmlformats.org/drawingml/2006/main"/>
           <a:p xmlns:a="http://schemas.openxmlformats.org/drawingml/2006/main">
             <a:pPr algn="l">
+              <a:buNone/>
               <a:defRPr sz="2175" b="0">
                 <a:solidFill>
                   <a:srgbClr val="58717A"/>
@@ -2129,6 +2138,7 @@
           <a:lstStyle xmlns:a="http://schemas.openxmlformats.org/drawingml/2006/main"/>
           <a:p xmlns:a="http://schemas.openxmlformats.org/drawingml/2006/main">
             <a:pPr algn="l">
+              <a:buNone/>
               <a:defRPr sz="4050" b="1">
                 <a:solidFill>
                   <a:srgbClr val="006D6D"/>
@@ -2186,6 +2196,7 @@
           <a:lstStyle xmlns:a="http://schemas.openxmlformats.org/drawingml/2006/main"/>
           <a:p xmlns:a="http://schemas.openxmlformats.org/drawingml/2006/main">
             <a:pPr algn="l">
+              <a:buNone/>
               <a:defRPr sz="2325" b="0">
                 <a:solidFill>
                   <a:srgbClr val="16323F"/>
@@ -2243,6 +2254,7 @@
           <a:lstStyle xmlns:a="http://schemas.openxmlformats.org/drawingml/2006/main"/>
           <a:p xmlns:a="http://schemas.openxmlformats.org/drawingml/2006/main">
             <a:pPr algn="l">
+              <a:buNone/>
               <a:defRPr sz="2025" b="1">
                 <a:solidFill>
                   <a:srgbClr val="16323F"/>
@@ -2300,6 +2312,7 @@
           <a:lstStyle xmlns:a="http://schemas.openxmlformats.org/drawingml/2006/main"/>
           <a:p xmlns:a="http://schemas.openxmlformats.org/drawingml/2006/main">
             <a:pPr algn="l">
+              <a:buNone/>
               <a:defRPr sz="1950" b="0">
                 <a:solidFill>
                   <a:srgbClr val="58717A"/>
@@ -2323,6 +2336,7 @@
           </a:p>
           <a:p xmlns:a="http://schemas.openxmlformats.org/drawingml/2006/main">
             <a:pPr algn="l">
+              <a:buNone/>
               <a:defRPr sz="1950" b="0">
                 <a:solidFill>
                   <a:srgbClr val="58717A"/>
@@ -2346,6 +2360,7 @@
           </a:p>
           <a:p xmlns:a="http://schemas.openxmlformats.org/drawingml/2006/main">
             <a:pPr algn="l">
+              <a:buNone/>
               <a:defRPr sz="1950" b="0">
                 <a:solidFill>
                   <a:srgbClr val="58717A"/>
@@ -2403,6 +2418,7 @@
           <a:lstStyle xmlns:a="http://schemas.openxmlformats.org/drawingml/2006/main"/>
           <a:p xmlns:a="http://schemas.openxmlformats.org/drawingml/2006/main">
             <a:pPr algn="l">
+              <a:buNone/>
               <a:defRPr sz="1725" b="0">
                 <a:solidFill>
                   <a:srgbClr val="58717A"/>
@@ -2489,6 +2505,7 @@
           <a:lstStyle xmlns:a="http://schemas.openxmlformats.org/drawingml/2006/main"/>
           <a:p xmlns:a="http://schemas.openxmlformats.org/drawingml/2006/main">
             <a:pPr algn="l">
+              <a:buNone/>
               <a:defRPr sz="3600" b="1">
                 <a:solidFill>
                   <a:srgbClr val="16323F"/>
@@ -2546,6 +2563,7 @@
           <a:lstStyle xmlns:a="http://schemas.openxmlformats.org/drawingml/2006/main"/>
           <a:p xmlns:a="http://schemas.openxmlformats.org/drawingml/2006/main">
             <a:pPr algn="l">
+              <a:buNone/>
               <a:defRPr sz="1875" b="0">
                 <a:solidFill>
                   <a:srgbClr val="58717A"/>
@@ -2603,6 +2621,7 @@
           <a:lstStyle xmlns:a="http://schemas.openxmlformats.org/drawingml/2006/main"/>
           <a:p xmlns:a="http://schemas.openxmlformats.org/drawingml/2006/main">
             <a:pPr algn="l">
+              <a:buNone/>
               <a:defRPr sz="1275" b="0">
                 <a:solidFill>
                   <a:srgbClr val="58717A"/>
@@ -2660,6 +2679,7 @@
           <a:lstStyle xmlns:a="http://schemas.openxmlformats.org/drawingml/2006/main"/>
           <a:p xmlns:a="http://schemas.openxmlformats.org/drawingml/2006/main">
             <a:pPr algn="r">
+              <a:buNone/>
               <a:defRPr sz="1275" b="0">
                 <a:solidFill>
                   <a:srgbClr val="58717A"/>
@@ -2717,6 +2737,7 @@
           <a:lstStyle xmlns:a="http://schemas.openxmlformats.org/drawingml/2006/main"/>
           <a:p xmlns:a="http://schemas.openxmlformats.org/drawingml/2006/main">
             <a:pPr algn="l">
+              <a:buNone/>
               <a:defRPr sz="3000" b="1">
                 <a:solidFill>
                   <a:srgbClr val="006D6D"/>
@@ -2774,6 +2795,7 @@
           <a:lstStyle xmlns:a="http://schemas.openxmlformats.org/drawingml/2006/main"/>
           <a:p xmlns:a="http://schemas.openxmlformats.org/drawingml/2006/main">
             <a:pPr algn="l">
+              <a:buNone/>
               <a:defRPr sz="2175" b="1">
                 <a:solidFill>
                   <a:srgbClr val="16323F"/>
@@ -2831,6 +2853,7 @@
           <a:lstStyle xmlns:a="http://schemas.openxmlformats.org/drawingml/2006/main"/>
           <a:p xmlns:a="http://schemas.openxmlformats.org/drawingml/2006/main">
             <a:pPr algn="l">
+              <a:buNone/>
               <a:defRPr sz="1875" b="0">
                 <a:solidFill>
                   <a:srgbClr val="58717A"/>
@@ -2888,6 +2911,7 @@
           <a:lstStyle xmlns:a="http://schemas.openxmlformats.org/drawingml/2006/main"/>
           <a:p xmlns:a="http://schemas.openxmlformats.org/drawingml/2006/main">
             <a:pPr algn="l">
+              <a:buNone/>
               <a:defRPr sz="3000" b="1">
                 <a:solidFill>
                   <a:srgbClr val="006D6D"/>
@@ -2945,6 +2969,7 @@
           <a:lstStyle xmlns:a="http://schemas.openxmlformats.org/drawingml/2006/main"/>
           <a:p xmlns:a="http://schemas.openxmlformats.org/drawingml/2006/main">
             <a:pPr algn="l">
+              <a:buNone/>
               <a:defRPr sz="2175" b="1">
                 <a:solidFill>
                   <a:srgbClr val="16323F"/>
@@ -3002,6 +3027,7 @@
           <a:lstStyle xmlns:a="http://schemas.openxmlformats.org/drawingml/2006/main"/>
           <a:p xmlns:a="http://schemas.openxmlformats.org/drawingml/2006/main">
             <a:pPr algn="l">
+              <a:buNone/>
               <a:defRPr sz="1875" b="0">
                 <a:solidFill>
                   <a:srgbClr val="58717A"/>
@@ -3059,6 +3085,7 @@
           <a:lstStyle xmlns:a="http://schemas.openxmlformats.org/drawingml/2006/main"/>
           <a:p xmlns:a="http://schemas.openxmlformats.org/drawingml/2006/main">
             <a:pPr algn="l">
+              <a:buNone/>
               <a:defRPr sz="3000" b="1">
                 <a:solidFill>
                   <a:srgbClr val="B87519"/>
@@ -3116,6 +3143,7 @@
           <a:lstStyle xmlns:a="http://schemas.openxmlformats.org/drawingml/2006/main"/>
           <a:p xmlns:a="http://schemas.openxmlformats.org/drawingml/2006/main">
             <a:pPr algn="l">
+              <a:buNone/>
               <a:defRPr sz="2175" b="1">
                 <a:solidFill>
                   <a:srgbClr val="16323F"/>
@@ -3173,6 +3201,7 @@
           <a:lstStyle xmlns:a="http://schemas.openxmlformats.org/drawingml/2006/main"/>
           <a:p xmlns:a="http://schemas.openxmlformats.org/drawingml/2006/main">
             <a:pPr algn="l">
+              <a:buNone/>
               <a:defRPr sz="1875" b="0">
                 <a:solidFill>
                   <a:srgbClr val="58717A"/>
@@ -3230,6 +3259,7 @@
           <a:lstStyle xmlns:a="http://schemas.openxmlformats.org/drawingml/2006/main"/>
           <a:p xmlns:a="http://schemas.openxmlformats.org/drawingml/2006/main">
             <a:pPr algn="l">
+              <a:buNone/>
               <a:defRPr sz="3000" b="1">
                 <a:solidFill>
                   <a:srgbClr val="006D6D"/>
@@ -3287,6 +3317,7 @@
           <a:lstStyle xmlns:a="http://schemas.openxmlformats.org/drawingml/2006/main"/>
           <a:p xmlns:a="http://schemas.openxmlformats.org/drawingml/2006/main">
             <a:pPr algn="l">
+              <a:buNone/>
               <a:defRPr sz="2175" b="1">
                 <a:solidFill>
                   <a:srgbClr val="16323F"/>
@@ -3344,6 +3375,7 @@
           <a:lstStyle xmlns:a="http://schemas.openxmlformats.org/drawingml/2006/main"/>
           <a:p xmlns:a="http://schemas.openxmlformats.org/drawingml/2006/main">
             <a:pPr algn="l">
+              <a:buNone/>
               <a:defRPr sz="1875" b="0">
                 <a:solidFill>
                   <a:srgbClr val="58717A"/>
@@ -3369,7 +3401,7 @@
       </p:sp>
       <p:cxnSp>
         <p:nvCxnSpPr>
-          <p:cNvPr id="37" name=""/>
+          <p:cNvPr id="56" name=""/>
           <p:cNvCxnSpPr>
             <a:stCxn xmlns:a="http://schemas.openxmlformats.org/drawingml/2006/main" id="6" idx="3"/>
             <a:endCxn xmlns:a="http://schemas.openxmlformats.org/drawingml/2006/main" id="9" idx="1"/>
@@ -3394,7 +3426,7 @@
       </p:cxnSp>
       <p:cxnSp>
         <p:nvCxnSpPr>
-          <p:cNvPr id="38" name=""/>
+          <p:cNvPr id="57" name=""/>
           <p:cNvCxnSpPr>
             <a:stCxn xmlns:a="http://schemas.openxmlformats.org/drawingml/2006/main" id="9" idx="3"/>
             <a:endCxn xmlns:a="http://schemas.openxmlformats.org/drawingml/2006/main" id="12" idx="1"/>
@@ -3419,7 +3451,7 @@
       </p:cxnSp>
       <p:cxnSp>
         <p:nvCxnSpPr>
-          <p:cNvPr id="39" name=""/>
+          <p:cNvPr id="58" name=""/>
           <p:cNvCxnSpPr>
             <a:stCxn xmlns:a="http://schemas.openxmlformats.org/drawingml/2006/main" id="12" idx="3"/>
             <a:endCxn xmlns:a="http://schemas.openxmlformats.org/drawingml/2006/main" id="15" idx="1"/>
@@ -3476,6 +3508,7 @@
           <a:lstStyle xmlns:a="http://schemas.openxmlformats.org/drawingml/2006/main"/>
           <a:p xmlns:a="http://schemas.openxmlformats.org/drawingml/2006/main">
             <a:pPr algn="l">
+              <a:buNone/>
               <a:defRPr sz="2175" b="1">
                 <a:solidFill>
                   <a:srgbClr val="006D6D"/>
@@ -3562,6 +3595,7 @@
           <a:lstStyle xmlns:a="http://schemas.openxmlformats.org/drawingml/2006/main"/>
           <a:p xmlns:a="http://schemas.openxmlformats.org/drawingml/2006/main">
             <a:pPr algn="l">
+              <a:buNone/>
               <a:defRPr sz="3600" b="1">
                 <a:solidFill>
                   <a:srgbClr val="16323F"/>
@@ -3619,6 +3653,7 @@
           <a:lstStyle xmlns:a="http://schemas.openxmlformats.org/drawingml/2006/main"/>
           <a:p xmlns:a="http://schemas.openxmlformats.org/drawingml/2006/main">
             <a:pPr algn="l">
+              <a:buNone/>
               <a:defRPr sz="1875" b="0">
                 <a:solidFill>
                   <a:srgbClr val="58717A"/>
@@ -3676,6 +3711,7 @@
           <a:lstStyle xmlns:a="http://schemas.openxmlformats.org/drawingml/2006/main"/>
           <a:p xmlns:a="http://schemas.openxmlformats.org/drawingml/2006/main">
             <a:pPr algn="l">
+              <a:buNone/>
               <a:defRPr sz="1275" b="0">
                 <a:solidFill>
                   <a:srgbClr val="58717A"/>
@@ -3733,6 +3769,7 @@
           <a:lstStyle xmlns:a="http://schemas.openxmlformats.org/drawingml/2006/main"/>
           <a:p xmlns:a="http://schemas.openxmlformats.org/drawingml/2006/main">
             <a:pPr algn="r">
+              <a:buNone/>
               <a:defRPr sz="1275" b="0">
                 <a:solidFill>
                   <a:srgbClr val="58717A"/>
@@ -3758,7 +3795,7 @@
       </p:sp>
       <p:graphicFrame>
         <p:nvGraphicFramePr>
-          <p:cNvPr id="11" name=""/>
+          <p:cNvPr id="13" name=""/>
           <p:cNvGraphicFramePr/>
           <p:nvPr/>
         </p:nvGraphicFramePr>
@@ -3783,7 +3820,9 @@
                     </a:bodyPr>
                     <a:lstStyle/>
                     <a:p>
-                      <a:pPr algn="l"/>
+                      <a:pPr algn="l">
+                        <a:buNone/>
+                      </a:pPr>
                       <a:r>
                         <a:rPr sz="1725" b="1">
                           <a:solidFill>
@@ -3810,7 +3849,9 @@
                     </a:bodyPr>
                     <a:lstStyle/>
                     <a:p>
-                      <a:pPr algn="ctr"/>
+                      <a:pPr algn="ctr">
+                        <a:buNone/>
+                      </a:pPr>
                       <a:r>
                         <a:rPr sz="1725" b="1">
                           <a:solidFill>
@@ -3837,7 +3878,9 @@
                     </a:bodyPr>
                     <a:lstStyle/>
                     <a:p>
-                      <a:pPr algn="ctr"/>
+                      <a:pPr algn="ctr">
+                        <a:buNone/>
+                      </a:pPr>
                       <a:r>
                         <a:rPr sz="1725" b="1">
                           <a:solidFill>
@@ -3866,7 +3909,9 @@
                     </a:bodyPr>
                     <a:lstStyle/>
                     <a:p>
-                      <a:pPr algn="l"/>
+                      <a:pPr algn="l">
+                        <a:buNone/>
+                      </a:pPr>
                       <a:r>
                         <a:rPr sz="2175" b="0">
                           <a:solidFill>
@@ -3893,7 +3938,9 @@
                     </a:bodyPr>
                     <a:lstStyle/>
                     <a:p>
-                      <a:pPr algn="ctr"/>
+                      <a:pPr algn="ctr">
+                        <a:buNone/>
+                      </a:pPr>
                       <a:r>
                         <a:rPr sz="2175" b="1">
                           <a:solidFill>
@@ -3920,7 +3967,9 @@
                     </a:bodyPr>
                     <a:lstStyle/>
                     <a:p>
-                      <a:pPr algn="ctr"/>
+                      <a:pPr algn="ctr">
+                        <a:buNone/>
+                      </a:pPr>
                       <a:r>
                         <a:rPr sz="2175" b="1">
                           <a:solidFill>
@@ -3949,7 +3998,9 @@
                     </a:bodyPr>
                     <a:lstStyle/>
                     <a:p>
-                      <a:pPr algn="l"/>
+                      <a:pPr algn="l">
+                        <a:buNone/>
+                      </a:pPr>
                       <a:r>
                         <a:rPr sz="2175" b="0">
                           <a:solidFill>
@@ -3976,7 +4027,9 @@
                     </a:bodyPr>
                     <a:lstStyle/>
                     <a:p>
-                      <a:pPr algn="ctr"/>
+                      <a:pPr algn="ctr">
+                        <a:buNone/>
+                      </a:pPr>
                       <a:r>
                         <a:rPr sz="2175" b="1">
                           <a:solidFill>
@@ -4003,7 +4056,9 @@
                     </a:bodyPr>
                     <a:lstStyle/>
                     <a:p>
-                      <a:pPr algn="ctr"/>
+                      <a:pPr algn="ctr">
+                        <a:buNone/>
+                      </a:pPr>
                       <a:r>
                         <a:rPr sz="2175" b="1">
                           <a:solidFill>
@@ -4032,7 +4087,9 @@
                     </a:bodyPr>
                     <a:lstStyle/>
                     <a:p>
-                      <a:pPr algn="l"/>
+                      <a:pPr algn="l">
+                        <a:buNone/>
+                      </a:pPr>
                       <a:r>
                         <a:rPr sz="2175" b="0">
                           <a:solidFill>
@@ -4059,7 +4116,9 @@
                     </a:bodyPr>
                     <a:lstStyle/>
                     <a:p>
-                      <a:pPr algn="ctr"/>
+                      <a:pPr algn="ctr">
+                        <a:buNone/>
+                      </a:pPr>
                       <a:r>
                         <a:rPr sz="2175" b="1">
                           <a:solidFill>
@@ -4086,7 +4145,9 @@
                     </a:bodyPr>
                     <a:lstStyle/>
                     <a:p>
-                      <a:pPr algn="ctr"/>
+                      <a:pPr algn="ctr">
+                        <a:buNone/>
+                      </a:pPr>
                       <a:r>
                         <a:rPr sz="2175" b="1">
                           <a:solidFill>
@@ -4115,7 +4176,9 @@
                     </a:bodyPr>
                     <a:lstStyle/>
                     <a:p>
-                      <a:pPr algn="l"/>
+                      <a:pPr algn="l">
+                        <a:buNone/>
+                      </a:pPr>
                       <a:r>
                         <a:rPr sz="2175" b="0">
                           <a:solidFill>
@@ -4142,7 +4205,9 @@
                     </a:bodyPr>
                     <a:lstStyle/>
                     <a:p>
-                      <a:pPr algn="ctr"/>
+                      <a:pPr algn="ctr">
+                        <a:buNone/>
+                      </a:pPr>
                       <a:r>
                         <a:rPr sz="2175" b="1">
                           <a:solidFill>
@@ -4169,7 +4234,9 @@
                     </a:bodyPr>
                     <a:lstStyle/>
                     <a:p>
-                      <a:pPr algn="ctr"/>
+                      <a:pPr algn="ctr">
+                        <a:buNone/>
+                      </a:pPr>
                       <a:r>
                         <a:rPr sz="2175" b="1">
                           <a:solidFill>
@@ -4228,6 +4295,7 @@
           <a:lstStyle xmlns:a="http://schemas.openxmlformats.org/drawingml/2006/main"/>
           <a:p xmlns:a="http://schemas.openxmlformats.org/drawingml/2006/main">
             <a:pPr algn="l">
+              <a:buNone/>
               <a:defRPr sz="2025" b="1">
                 <a:solidFill>
                   <a:srgbClr val="B87519"/>
@@ -4314,6 +4382,7 @@
           <a:lstStyle xmlns:a="http://schemas.openxmlformats.org/drawingml/2006/main"/>
           <a:p xmlns:a="http://schemas.openxmlformats.org/drawingml/2006/main">
             <a:pPr algn="l">
+              <a:buNone/>
               <a:defRPr sz="3600" b="1">
                 <a:solidFill>
                   <a:srgbClr val="16323F"/>
@@ -4371,6 +4440,7 @@
           <a:lstStyle xmlns:a="http://schemas.openxmlformats.org/drawingml/2006/main"/>
           <a:p xmlns:a="http://schemas.openxmlformats.org/drawingml/2006/main">
             <a:pPr algn="l">
+              <a:buNone/>
               <a:defRPr sz="1875" b="0">
                 <a:solidFill>
                   <a:srgbClr val="58717A"/>
@@ -4428,6 +4498,7 @@
           <a:lstStyle xmlns:a="http://schemas.openxmlformats.org/drawingml/2006/main"/>
           <a:p xmlns:a="http://schemas.openxmlformats.org/drawingml/2006/main">
             <a:pPr algn="l">
+              <a:buNone/>
               <a:defRPr sz="1275" b="0">
                 <a:solidFill>
                   <a:srgbClr val="58717A"/>
@@ -4485,6 +4556,7 @@
           <a:lstStyle xmlns:a="http://schemas.openxmlformats.org/drawingml/2006/main"/>
           <a:p xmlns:a="http://schemas.openxmlformats.org/drawingml/2006/main">
             <a:pPr algn="r">
+              <a:buNone/>
               <a:defRPr sz="1275" b="0">
                 <a:solidFill>
                   <a:srgbClr val="58717A"/>
@@ -4546,6 +4618,7 @@
           <a:lstStyle xmlns:a="http://schemas.openxmlformats.org/drawingml/2006/main"/>
           <a:p xmlns:a="http://schemas.openxmlformats.org/drawingml/2006/main">
             <a:pPr algn="ctr">
+              <a:buNone/>
               <a:defRPr sz="2175" b="1">
                 <a:solidFill>
                   <a:srgbClr val="006D6D"/>
@@ -4603,6 +4676,7 @@
           <a:lstStyle xmlns:a="http://schemas.openxmlformats.org/drawingml/2006/main"/>
           <a:p xmlns:a="http://schemas.openxmlformats.org/drawingml/2006/main">
             <a:pPr algn="l">
+              <a:buNone/>
               <a:defRPr sz="2025" b="0">
                 <a:solidFill>
                   <a:srgbClr val="16323F"/>
@@ -4621,7 +4695,7 @@
                 <a:ea typeface="Arial"/>
                 <a:cs typeface="Arial"/>
               </a:rPr>
-              <a:t>Maps source content into candidate records.</a:t>
+              <a:t>Reads text and PDF page images into record proposals.</a:t>
             </a:r>
           </a:p>
         </p:txBody>
@@ -4664,6 +4738,7 @@
           <a:lstStyle xmlns:a="http://schemas.openxmlformats.org/drawingml/2006/main"/>
           <a:p xmlns:a="http://schemas.openxmlformats.org/drawingml/2006/main">
             <a:pPr algn="ctr">
+              <a:buNone/>
               <a:defRPr sz="2175" b="1">
                 <a:solidFill>
                   <a:srgbClr val="B87519"/>
@@ -4721,6 +4796,7 @@
           <a:lstStyle xmlns:a="http://schemas.openxmlformats.org/drawingml/2006/main"/>
           <a:p xmlns:a="http://schemas.openxmlformats.org/drawingml/2006/main">
             <a:pPr algn="l">
+              <a:buNone/>
               <a:defRPr sz="2025" b="0">
                 <a:solidFill>
                   <a:srgbClr val="16323F"/>
@@ -4782,6 +4858,7 @@
           <a:lstStyle xmlns:a="http://schemas.openxmlformats.org/drawingml/2006/main"/>
           <a:p xmlns:a="http://schemas.openxmlformats.org/drawingml/2006/main">
             <a:pPr algn="ctr">
+              <a:buNone/>
               <a:defRPr sz="2175" b="1">
                 <a:solidFill>
                   <a:srgbClr val="006D6D"/>
@@ -4839,6 +4916,7 @@
           <a:lstStyle xmlns:a="http://schemas.openxmlformats.org/drawingml/2006/main"/>
           <a:p xmlns:a="http://schemas.openxmlformats.org/drawingml/2006/main">
             <a:pPr algn="l">
+              <a:buNone/>
               <a:defRPr sz="2025" b="0">
                 <a:solidFill>
                   <a:srgbClr val="16323F"/>
@@ -4864,7 +4942,7 @@
       </p:sp>
       <p:cxnSp>
         <p:nvCxnSpPr>
-          <p:cNvPr id="24" name=""/>
+          <p:cNvPr id="36" name=""/>
           <p:cNvCxnSpPr>
             <a:stCxn xmlns:a="http://schemas.openxmlformats.org/drawingml/2006/main" id="5" idx="3"/>
             <a:endCxn xmlns:a="http://schemas.openxmlformats.org/drawingml/2006/main" id="7" idx="1"/>
@@ -4889,7 +4967,7 @@
       </p:cxnSp>
       <p:cxnSp>
         <p:nvCxnSpPr>
-          <p:cNvPr id="25" name=""/>
+          <p:cNvPr id="37" name=""/>
           <p:cNvCxnSpPr>
             <a:stCxn xmlns:a="http://schemas.openxmlformats.org/drawingml/2006/main" id="7" idx="3"/>
             <a:endCxn xmlns:a="http://schemas.openxmlformats.org/drawingml/2006/main" id="9" idx="1"/>
@@ -4946,9 +5024,10 @@
           <a:lstStyle xmlns:a="http://schemas.openxmlformats.org/drawingml/2006/main"/>
           <a:p xmlns:a="http://schemas.openxmlformats.org/drawingml/2006/main">
             <a:pPr algn="l">
+              <a:buNone/>
               <a:defRPr sz="2025" b="1">
                 <a:solidFill>
-                  <a:srgbClr val="B87519"/>
+                  <a:srgbClr val="006D6D"/>
                 </a:solidFill>
                 <a:latin typeface="Arial"/>
                 <a:ea typeface="Arial"/>
@@ -4958,13 +5037,14 @@
             <a:r>
               <a:rPr sz="2025" b="1">
                 <a:solidFill>
-                  <a:srgbClr val="B87519"/>
-                </a:solidFill>
-                <a:latin typeface="Arial"/>
-                <a:ea typeface="Arial"/>
-                <a:cs typeface="Arial"/>
-              </a:rPr>
-              <a:t>AI integration is in progress. Live extraction validation is pending.</a:t>
+                  <a:srgbClr val="006D6D"/>
+                </a:solidFill>
+                <a:latin typeface="Arial"/>
+                <a:ea typeface="Arial"/>
+                <a:cs typeface="Arial"/>
+              </a:rPr>
+              <a:t>Live Fireworks checks on synthetic text and PDF: 3 records each.
+Reviewed PDF import: 180 confirmed packs, 0 unresolved.</a:t>
             </a:r>
           </a:p>
         </p:txBody>
@@ -5032,6 +5112,7 @@
           <a:lstStyle xmlns:a="http://schemas.openxmlformats.org/drawingml/2006/main"/>
           <a:p xmlns:a="http://schemas.openxmlformats.org/drawingml/2006/main">
             <a:pPr algn="l">
+              <a:buNone/>
               <a:defRPr sz="3600" b="1">
                 <a:solidFill>
                   <a:srgbClr val="FFFFFF"/>
@@ -5089,6 +5170,7 @@
           <a:lstStyle xmlns:a="http://schemas.openxmlformats.org/drawingml/2006/main"/>
           <a:p xmlns:a="http://schemas.openxmlformats.org/drawingml/2006/main">
             <a:pPr algn="l">
+              <a:buNone/>
               <a:defRPr sz="1275" b="0">
                 <a:solidFill>
                   <a:srgbClr val="9CDED0"/>
@@ -5146,6 +5228,7 @@
           <a:lstStyle xmlns:a="http://schemas.openxmlformats.org/drawingml/2006/main"/>
           <a:p xmlns:a="http://schemas.openxmlformats.org/drawingml/2006/main">
             <a:pPr algn="r">
+              <a:buNone/>
               <a:defRPr sz="1275" b="0">
                 <a:solidFill>
                   <a:srgbClr val="9CDED0"/>
@@ -5203,6 +5286,7 @@
           <a:lstStyle xmlns:a="http://schemas.openxmlformats.org/drawingml/2006/main"/>
           <a:p xmlns:a="http://schemas.openxmlformats.org/drawingml/2006/main">
             <a:pPr algn="l">
+              <a:buNone/>
               <a:defRPr sz="6225" b="1">
                 <a:solidFill>
                   <a:srgbClr val="FFFFFF"/>
@@ -5260,6 +5344,7 @@
           <a:lstStyle xmlns:a="http://schemas.openxmlformats.org/drawingml/2006/main"/>
           <a:p xmlns:a="http://schemas.openxmlformats.org/drawingml/2006/main">
             <a:pPr algn="l">
+              <a:buNone/>
               <a:defRPr sz="2550" b="0">
                 <a:solidFill>
                   <a:srgbClr val="9CDED0"/>
@@ -5317,6 +5402,7 @@
           <a:lstStyle xmlns:a="http://schemas.openxmlformats.org/drawingml/2006/main"/>
           <a:p xmlns:a="http://schemas.openxmlformats.org/drawingml/2006/main">
             <a:pPr algn="l">
+              <a:buNone/>
               <a:defRPr sz="1950" b="0">
                 <a:solidFill>
                   <a:srgbClr val="E9B864"/>
@@ -5374,6 +5460,7 @@
           <a:lstStyle xmlns:a="http://schemas.openxmlformats.org/drawingml/2006/main"/>
           <a:p xmlns:a="http://schemas.openxmlformats.org/drawingml/2006/main">
             <a:pPr algn="l">
+              <a:buNone/>
               <a:defRPr sz="1875" b="1">
                 <a:solidFill>
                   <a:srgbClr val="9CDED0"/>
@@ -5431,6 +5518,7 @@
           <a:lstStyle xmlns:a="http://schemas.openxmlformats.org/drawingml/2006/main"/>
           <a:p xmlns:a="http://schemas.openxmlformats.org/drawingml/2006/main">
             <a:pPr algn="l">
+              <a:buNone/>
               <a:defRPr sz="2100" b="0">
                 <a:solidFill>
                   <a:srgbClr val="FFFFFF"/>
@@ -5488,6 +5576,7 @@
           <a:lstStyle xmlns:a="http://schemas.openxmlformats.org/drawingml/2006/main"/>
           <a:p xmlns:a="http://schemas.openxmlformats.org/drawingml/2006/main">
             <a:pPr algn="l">
+              <a:buNone/>
               <a:defRPr sz="1875" b="1">
                 <a:solidFill>
                   <a:srgbClr val="9CDED0"/>
@@ -5545,6 +5634,7 @@
           <a:lstStyle xmlns:a="http://schemas.openxmlformats.org/drawingml/2006/main"/>
           <a:p xmlns:a="http://schemas.openxmlformats.org/drawingml/2006/main">
             <a:pPr algn="l">
+              <a:buNone/>
               <a:defRPr sz="2100" b="0">
                 <a:solidFill>
                   <a:srgbClr val="FFFFFF"/>
@@ -5631,6 +5721,7 @@
           <a:lstStyle xmlns:a="http://schemas.openxmlformats.org/drawingml/2006/main"/>
           <a:p xmlns:a="http://schemas.openxmlformats.org/drawingml/2006/main">
             <a:pPr algn="l">
+              <a:buNone/>
               <a:defRPr sz="3600" b="1">
                 <a:solidFill>
                   <a:srgbClr val="16323F"/>
@@ -5688,6 +5779,7 @@
           <a:lstStyle xmlns:a="http://schemas.openxmlformats.org/drawingml/2006/main"/>
           <a:p xmlns:a="http://schemas.openxmlformats.org/drawingml/2006/main">
             <a:pPr algn="l">
+              <a:buNone/>
               <a:defRPr sz="1875" b="0">
                 <a:solidFill>
                   <a:srgbClr val="58717A"/>
@@ -5706,7 +5798,7 @@
                 <a:ea typeface="Arial"/>
                 <a:cs typeface="Arial"/>
               </a:rPr>
-              <a:t>Run the same drill manually and with RecallScope on permissioned records</a:t>
+              <a:t>Next: compare manual and RecallScope drills on manufacturer records</a:t>
             </a:r>
           </a:p>
         </p:txBody>
@@ -5745,6 +5837,7 @@
           <a:lstStyle xmlns:a="http://schemas.openxmlformats.org/drawingml/2006/main"/>
           <a:p xmlns:a="http://schemas.openxmlformats.org/drawingml/2006/main">
             <a:pPr algn="l">
+              <a:buNone/>
               <a:defRPr sz="1275" b="0">
                 <a:solidFill>
                   <a:srgbClr val="58717A"/>
@@ -5802,6 +5895,7 @@
           <a:lstStyle xmlns:a="http://schemas.openxmlformats.org/drawingml/2006/main"/>
           <a:p xmlns:a="http://schemas.openxmlformats.org/drawingml/2006/main">
             <a:pPr algn="r">
+              <a:buNone/>
               <a:defRPr sz="1275" b="0">
                 <a:solidFill>
                   <a:srgbClr val="58717A"/>
@@ -5827,7 +5921,7 @@
       </p:sp>
       <p:graphicFrame>
         <p:nvGraphicFramePr>
-          <p:cNvPr id="11" name=""/>
+          <p:cNvPr id="13" name=""/>
           <p:cNvGraphicFramePr/>
           <p:nvPr/>
         </p:nvGraphicFramePr>
@@ -5851,7 +5945,9 @@
                     </a:bodyPr>
                     <a:lstStyle/>
                     <a:p>
-                      <a:pPr algn="l"/>
+                      <a:pPr algn="l">
+                        <a:buNone/>
+                      </a:pPr>
                       <a:r>
                         <a:rPr sz="1725" b="1">
                           <a:solidFill>
@@ -5878,7 +5974,9 @@
                     </a:bodyPr>
                     <a:lstStyle/>
                     <a:p>
-                      <a:pPr algn="ctr"/>
+                      <a:pPr algn="ctr">
+                        <a:buNone/>
+                      </a:pPr>
                       <a:r>
                         <a:rPr sz="1725" b="1">
                           <a:solidFill>
@@ -5907,7 +6005,9 @@
                     </a:bodyPr>
                     <a:lstStyle/>
                     <a:p>
-                      <a:pPr algn="l"/>
+                      <a:pPr algn="l">
+                        <a:buNone/>
+                      </a:pPr>
                       <a:r>
                         <a:rPr sz="2175" b="0">
                           <a:solidFill>
@@ -5934,7 +6034,9 @@
                     </a:bodyPr>
                     <a:lstStyle/>
                     <a:p>
-                      <a:pPr algn="ctr"/>
+                      <a:pPr algn="ctr">
+                        <a:buNone/>
+                      </a:pPr>
                       <a:r>
                         <a:rPr sz="2175" b="1">
                           <a:solidFill>
@@ -5963,7 +6065,9 @@
                     </a:bodyPr>
                     <a:lstStyle/>
                     <a:p>
-                      <a:pPr algn="l"/>
+                      <a:pPr algn="l">
+                        <a:buNone/>
+                      </a:pPr>
                       <a:r>
                         <a:rPr sz="2175" b="0">
                           <a:solidFill>
@@ -5990,7 +6094,9 @@
                     </a:bodyPr>
                     <a:lstStyle/>
                     <a:p>
-                      <a:pPr algn="ctr"/>
+                      <a:pPr algn="ctr">
+                        <a:buNone/>
+                      </a:pPr>
                       <a:r>
                         <a:rPr sz="2175" b="1">
                           <a:solidFill>
@@ -6019,7 +6125,9 @@
                     </a:bodyPr>
                     <a:lstStyle/>
                     <a:p>
-                      <a:pPr algn="l"/>
+                      <a:pPr algn="l">
+                        <a:buNone/>
+                      </a:pPr>
                       <a:r>
                         <a:rPr sz="2175" b="0">
                           <a:solidFill>
@@ -6046,7 +6154,9 @@
                     </a:bodyPr>
                     <a:lstStyle/>
                     <a:p>
-                      <a:pPr algn="ctr"/>
+                      <a:pPr algn="ctr">
+                        <a:buNone/>
+                      </a:pPr>
                       <a:r>
                         <a:rPr sz="2175" b="1">
                           <a:solidFill>
@@ -6075,7 +6185,9 @@
                     </a:bodyPr>
                     <a:lstStyle/>
                     <a:p>
-                      <a:pPr algn="l"/>
+                      <a:pPr algn="l">
+                        <a:buNone/>
+                      </a:pPr>
                       <a:r>
                         <a:rPr sz="2175" b="0">
                           <a:solidFill>
@@ -6102,7 +6214,9 @@
                     </a:bodyPr>
                     <a:lstStyle/>
                     <a:p>
-                      <a:pPr algn="ctr"/>
+                      <a:pPr algn="ctr">
+                        <a:buNone/>
+                      </a:pPr>
                       <a:r>
                         <a:rPr sz="2175" b="1">
                           <a:solidFill>
@@ -6161,6 +6275,7 @@
           <a:lstStyle xmlns:a="http://schemas.openxmlformats.org/drawingml/2006/main"/>
           <a:p xmlns:a="http://schemas.openxmlformats.org/drawingml/2006/main">
             <a:pPr algn="l">
+              <a:buNone/>
               <a:defRPr sz="2100" b="1">
                 <a:solidFill>
                   <a:srgbClr val="006D6D"/>
@@ -6179,7 +6294,7 @@
                 <a:ea typeface="Arial"/>
                 <a:cs typeface="Arial"/>
               </a:rPr>
-              <a:t>Pilot results will determine the product scope and the proposed price.</a:t>
+              <a:t>Manufacturer pilots, deployment, video and GitHub push remain pending.</a:t>
             </a:r>
           </a:p>
         </p:txBody>
@@ -6247,6 +6362,7 @@
           <a:lstStyle xmlns:a="http://schemas.openxmlformats.org/drawingml/2006/main"/>
           <a:p xmlns:a="http://schemas.openxmlformats.org/drawingml/2006/main">
             <a:pPr algn="l">
+              <a:buNone/>
               <a:defRPr sz="3600" b="1">
                 <a:solidFill>
                   <a:srgbClr val="FFFFFF"/>
@@ -6304,6 +6420,7 @@
           <a:lstStyle xmlns:a="http://schemas.openxmlformats.org/drawingml/2006/main"/>
           <a:p xmlns:a="http://schemas.openxmlformats.org/drawingml/2006/main">
             <a:pPr algn="l">
+              <a:buNone/>
               <a:defRPr sz="1275" b="0">
                 <a:solidFill>
                   <a:srgbClr val="9CDED0"/>
@@ -6361,6 +6478,7 @@
           <a:lstStyle xmlns:a="http://schemas.openxmlformats.org/drawingml/2006/main"/>
           <a:p xmlns:a="http://schemas.openxmlformats.org/drawingml/2006/main">
             <a:pPr algn="r">
+              <a:buNone/>
               <a:defRPr sz="1275" b="0">
                 <a:solidFill>
                   <a:srgbClr val="9CDED0"/>
@@ -6418,6 +6536,7 @@
           <a:lstStyle xmlns:a="http://schemas.openxmlformats.org/drawingml/2006/main"/>
           <a:p xmlns:a="http://schemas.openxmlformats.org/drawingml/2006/main">
             <a:pPr algn="l">
+              <a:buNone/>
               <a:defRPr sz="4575" b="1">
                 <a:solidFill>
                   <a:srgbClr val="FFFFFF"/>
@@ -6441,6 +6560,7 @@
           </a:p>
           <a:p xmlns:a="http://schemas.openxmlformats.org/drawingml/2006/main">
             <a:pPr algn="l">
+              <a:buNone/>
               <a:defRPr sz="4575" b="1">
                 <a:solidFill>
                   <a:srgbClr val="FFFFFF"/>
@@ -6498,6 +6618,7 @@
           <a:lstStyle xmlns:a="http://schemas.openxmlformats.org/drawingml/2006/main"/>
           <a:p xmlns:a="http://schemas.openxmlformats.org/drawingml/2006/main">
             <a:pPr algn="l">
+              <a:buNone/>
               <a:defRPr sz="2550" b="0">
                 <a:solidFill>
                   <a:srgbClr val="9CDED0"/>
@@ -6555,6 +6676,7 @@
           <a:lstStyle xmlns:a="http://schemas.openxmlformats.org/drawingml/2006/main"/>
           <a:p xmlns:a="http://schemas.openxmlformats.org/drawingml/2006/main">
             <a:pPr algn="l">
+              <a:buNone/>
               <a:defRPr sz="2100" b="0">
                 <a:solidFill>
                   <a:srgbClr val="FFFFFF"/>

</xml_diff>

<commit_message>
Prepare RecallScope for official GitHub publication
</commit_message>
<xml_diff>
--- a/docs/RecallScope-Pitch.pptx
+++ b/docs/RecallScope-Pitch.pptx
@@ -2,20 +2,20 @@
 <file path=ppt/presentation.xml><?xml version="1.0" encoding="utf-8"?>
 <p:presentation xmlns:p="http://schemas.openxmlformats.org/presentationml/2006/main">
   <p:sldMasterIdLst>
-    <p:sldMasterId xmlns:r="http://schemas.openxmlformats.org/officeDocument/2006/relationships" id="2147483648" r:id="R34855c77032d4f91"/>
+    <p:sldMasterId xmlns:r="http://schemas.openxmlformats.org/officeDocument/2006/relationships" id="2147483648" r:id="R15759166712a47d7"/>
   </p:sldMasterIdLst>
   <p:notesMasterIdLst>
-    <p:notesMasterId xmlns:r="http://schemas.openxmlformats.org/officeDocument/2006/relationships" r:id="R594c1cdbb043402b"/>
+    <p:notesMasterId xmlns:r="http://schemas.openxmlformats.org/officeDocument/2006/relationships" r:id="R305cb4f172e84a44"/>
   </p:notesMasterIdLst>
   <p:sldIdLst>
-    <p:sldId xmlns:r="http://schemas.openxmlformats.org/officeDocument/2006/relationships" id="256" r:id="R9b05f7be196f4a67"/>
-    <p:sldId xmlns:r="http://schemas.openxmlformats.org/officeDocument/2006/relationships" id="257" r:id="Re4e841a156fd4b94"/>
-    <p:sldId xmlns:r="http://schemas.openxmlformats.org/officeDocument/2006/relationships" id="258" r:id="R66f835e6567f4899"/>
-    <p:sldId xmlns:r="http://schemas.openxmlformats.org/officeDocument/2006/relationships" id="259" r:id="R6b1da41125884173"/>
-    <p:sldId xmlns:r="http://schemas.openxmlformats.org/officeDocument/2006/relationships" id="260" r:id="R8ee3c07e1fa44dfd"/>
-    <p:sldId xmlns:r="http://schemas.openxmlformats.org/officeDocument/2006/relationships" id="261" r:id="R08203ca6ae0e406b"/>
-    <p:sldId xmlns:r="http://schemas.openxmlformats.org/officeDocument/2006/relationships" id="262" r:id="R8f2f575a7989444d"/>
-    <p:sldId xmlns:r="http://schemas.openxmlformats.org/officeDocument/2006/relationships" id="263" r:id="R8180b45f837846ca"/>
+    <p:sldId xmlns:r="http://schemas.openxmlformats.org/officeDocument/2006/relationships" id="256" r:id="R52f05f7b37584ff9"/>
+    <p:sldId xmlns:r="http://schemas.openxmlformats.org/officeDocument/2006/relationships" id="257" r:id="Re1f7a7bacb9945ec"/>
+    <p:sldId xmlns:r="http://schemas.openxmlformats.org/officeDocument/2006/relationships" id="258" r:id="Rdb3c194d0fc9404a"/>
+    <p:sldId xmlns:r="http://schemas.openxmlformats.org/officeDocument/2006/relationships" id="259" r:id="Rafbfc58586404d00"/>
+    <p:sldId xmlns:r="http://schemas.openxmlformats.org/officeDocument/2006/relationships" id="260" r:id="R5921bb8b0aab48e1"/>
+    <p:sldId xmlns:r="http://schemas.openxmlformats.org/officeDocument/2006/relationships" id="261" r:id="R8bd6d7cd5a264602"/>
+    <p:sldId xmlns:r="http://schemas.openxmlformats.org/officeDocument/2006/relationships" id="262" r:id="R91b3f8c4d9e84900"/>
+    <p:sldId xmlns:r="http://schemas.openxmlformats.org/officeDocument/2006/relationships" id="263" r:id="Rc7fa8375cb4a476b"/>
   </p:sldIdLst>
   <p:sldSz cx="12192000" cy="6858000"/>
   <p:notesSz cx="6858000" cy="9144000"/>
@@ -869,7 +869,7 @@
           <a:lstStyle xmlns:a="http://schemas.openxmlformats.org/drawingml/2006/main"/>
           <a:p xmlns:a="http://schemas.openxmlformats.org/drawingml/2006/main">
             <a:r>
-              <a:t>This is a proposed validation plan, not completed research. Use permissioned and appropriately handled manufacturer records. Establish a human-reviewed expected trace before comparing outputs. Measure completion time without promising any reduction. FDA June 2026 tabletop exercise update says proactive supply-chain coordination drove the strongest results more than any particular technology: https://www.fda.gov/food/hfp-constituent-updates/fda-releases-report-traceability-readiness-tabletop-exercises-and-updated-faqs . This supports explicitly examining information gaps and handoffs rather than claiming that software alone resolves traceability. Live Fireworks extraction checks have passed on small synthetic text and PDF fixtures. That result does not replace the proposed manufacturer pilot. Public deployment, the final demo video and GitHub push remain pending. No exact automated-test count is asserted in this deck.</a:t>
+              <a:t>This is a proposed validation plan, not completed research. Use permissioned and appropriately handled manufacturer records. Establish a human-reviewed expected trace before comparing outputs. Measure completion time without promising any reduction. FDA June 2026 tabletop exercise update says proactive supply-chain coordination drove the strongest results more than any particular technology: https://www.fda.gov/food/hfp-constituent-updates/fda-releases-report-traceability-readiness-tabletop-exercises-and-updated-faqs . This supports explicitly examining information gaps and handoffs rather than claiming that software alone resolves traceability. Live Fireworks extraction checks have passed on small synthetic text and PDF fixtures. That result does not replace the proposed manufacturer pilot. Public deployment and the final demo video remain pending. The source release belongs to the official Team Console repository: https://github.com/HackIndiaXYZ/ai-first-startup-hackathon-build-a-startup-using-ai-only-console . No exact automated-test count is asserted in this deck.</a:t>
             </a:r>
           </a:p>
         </p:txBody>
@@ -1007,7 +1007,7 @@
   </p:cSld>
   <p:clrMap bg1="lt1" tx1="dk1" bg2="lt2" tx2="dk2" accent1="accent1" accent2="accent2" accent3="accent3" accent4="accent4" accent5="accent5" accent6="accent6" hlink="hlink" folHlink="folHlink"/>
   <p:sldLayoutIdLst>
-    <p:sldLayoutId xmlns:r="http://schemas.openxmlformats.org/officeDocument/2006/relationships" id="2147483649" r:id="Re6c9437af1334bc1"/>
+    <p:sldLayoutId xmlns:r="http://schemas.openxmlformats.org/officeDocument/2006/relationships" id="2147483649" r:id="R6f0d58c904774fda"/>
   </p:sldLayoutIdLst>
   <p:txStyles>
     <p:titleStyle>
@@ -3401,7 +3401,7 @@
       </p:sp>
       <p:cxnSp>
         <p:nvCxnSpPr>
-          <p:cNvPr id="56" name=""/>
+          <p:cNvPr id="75" name=""/>
           <p:cNvCxnSpPr>
             <a:stCxn xmlns:a="http://schemas.openxmlformats.org/drawingml/2006/main" id="6" idx="3"/>
             <a:endCxn xmlns:a="http://schemas.openxmlformats.org/drawingml/2006/main" id="9" idx="1"/>
@@ -3426,7 +3426,7 @@
       </p:cxnSp>
       <p:cxnSp>
         <p:nvCxnSpPr>
-          <p:cNvPr id="57" name=""/>
+          <p:cNvPr id="76" name=""/>
           <p:cNvCxnSpPr>
             <a:stCxn xmlns:a="http://schemas.openxmlformats.org/drawingml/2006/main" id="9" idx="3"/>
             <a:endCxn xmlns:a="http://schemas.openxmlformats.org/drawingml/2006/main" id="12" idx="1"/>
@@ -3451,7 +3451,7 @@
       </p:cxnSp>
       <p:cxnSp>
         <p:nvCxnSpPr>
-          <p:cNvPr id="58" name=""/>
+          <p:cNvPr id="77" name=""/>
           <p:cNvCxnSpPr>
             <a:stCxn xmlns:a="http://schemas.openxmlformats.org/drawingml/2006/main" id="12" idx="3"/>
             <a:endCxn xmlns:a="http://schemas.openxmlformats.org/drawingml/2006/main" id="15" idx="1"/>
@@ -4942,7 +4942,7 @@
       </p:sp>
       <p:cxnSp>
         <p:nvCxnSpPr>
-          <p:cNvPr id="36" name=""/>
+          <p:cNvPr id="48" name=""/>
           <p:cNvCxnSpPr>
             <a:stCxn xmlns:a="http://schemas.openxmlformats.org/drawingml/2006/main" id="5" idx="3"/>
             <a:endCxn xmlns:a="http://schemas.openxmlformats.org/drawingml/2006/main" id="7" idx="1"/>
@@ -4967,7 +4967,7 @@
       </p:cxnSp>
       <p:cxnSp>
         <p:nvCxnSpPr>
-          <p:cNvPr id="37" name=""/>
+          <p:cNvPr id="49" name=""/>
           <p:cNvCxnSpPr>
             <a:stCxn xmlns:a="http://schemas.openxmlformats.org/drawingml/2006/main" id="7" idx="3"/>
             <a:endCxn xmlns:a="http://schemas.openxmlformats.org/drawingml/2006/main" id="9" idx="1"/>
@@ -6294,7 +6294,7 @@
                 <a:ea typeface="Arial"/>
                 <a:cs typeface="Arial"/>
               </a:rPr>
-              <a:t>Manufacturer pilots, deployment, video and GitHub push remain pending.</a:t>
+              <a:t>Manufacturer pilots, public deployment and the final video remain pending.</a:t>
             </a:r>
           </a:p>
         </p:txBody>

</xml_diff>

<commit_message>
Present a complete RecallScope showcase with connected evidence
</commit_message>
<xml_diff>
--- a/docs/RecallScope-Pitch.pptx
+++ b/docs/RecallScope-Pitch.pptx
@@ -2,20 +2,20 @@
 <file path=ppt/presentation.xml><?xml version="1.0" encoding="utf-8"?>
 <p:presentation xmlns:p="http://schemas.openxmlformats.org/presentationml/2006/main">
   <p:sldMasterIdLst>
-    <p:sldMasterId xmlns:r="http://schemas.openxmlformats.org/officeDocument/2006/relationships" id="2147483648" r:id="R15759166712a47d7"/>
+    <p:sldMasterId xmlns:r="http://schemas.openxmlformats.org/officeDocument/2006/relationships" id="2147483648" r:id="R53e763b218b94bc4"/>
   </p:sldMasterIdLst>
   <p:notesMasterIdLst>
-    <p:notesMasterId xmlns:r="http://schemas.openxmlformats.org/officeDocument/2006/relationships" r:id="R305cb4f172e84a44"/>
+    <p:notesMasterId xmlns:r="http://schemas.openxmlformats.org/officeDocument/2006/relationships" r:id="Re7a0f3d9085c4ffd"/>
   </p:notesMasterIdLst>
   <p:sldIdLst>
-    <p:sldId xmlns:r="http://schemas.openxmlformats.org/officeDocument/2006/relationships" id="256" r:id="R52f05f7b37584ff9"/>
-    <p:sldId xmlns:r="http://schemas.openxmlformats.org/officeDocument/2006/relationships" id="257" r:id="Re1f7a7bacb9945ec"/>
-    <p:sldId xmlns:r="http://schemas.openxmlformats.org/officeDocument/2006/relationships" id="258" r:id="Rdb3c194d0fc9404a"/>
-    <p:sldId xmlns:r="http://schemas.openxmlformats.org/officeDocument/2006/relationships" id="259" r:id="Rafbfc58586404d00"/>
-    <p:sldId xmlns:r="http://schemas.openxmlformats.org/officeDocument/2006/relationships" id="260" r:id="R5921bb8b0aab48e1"/>
-    <p:sldId xmlns:r="http://schemas.openxmlformats.org/officeDocument/2006/relationships" id="261" r:id="R8bd6d7cd5a264602"/>
-    <p:sldId xmlns:r="http://schemas.openxmlformats.org/officeDocument/2006/relationships" id="262" r:id="R91b3f8c4d9e84900"/>
-    <p:sldId xmlns:r="http://schemas.openxmlformats.org/officeDocument/2006/relationships" id="263" r:id="Rc7fa8375cb4a476b"/>
+    <p:sldId xmlns:r="http://schemas.openxmlformats.org/officeDocument/2006/relationships" id="256" r:id="R11f4eef862484158"/>
+    <p:sldId xmlns:r="http://schemas.openxmlformats.org/officeDocument/2006/relationships" id="257" r:id="R1f990c554b1942ca"/>
+    <p:sldId xmlns:r="http://schemas.openxmlformats.org/officeDocument/2006/relationships" id="258" r:id="R3a61c693378d4ccd"/>
+    <p:sldId xmlns:r="http://schemas.openxmlformats.org/officeDocument/2006/relationships" id="259" r:id="R542d0c98bb3d47b8"/>
+    <p:sldId xmlns:r="http://schemas.openxmlformats.org/officeDocument/2006/relationships" id="260" r:id="Re6b83f22c5c640d6"/>
+    <p:sldId xmlns:r="http://schemas.openxmlformats.org/officeDocument/2006/relationships" id="261" r:id="R10f0400e01754e6b"/>
+    <p:sldId xmlns:r="http://schemas.openxmlformats.org/officeDocument/2006/relationships" id="262" r:id="R741465ab0cfc438c"/>
+    <p:sldId xmlns:r="http://schemas.openxmlformats.org/officeDocument/2006/relationships" id="263" r:id="R230c1791f7024c4d"/>
   </p:sldIdLst>
   <p:sldSz cx="12192000" cy="6858000"/>
   <p:notesSz cx="6858000" cy="9144000"/>
@@ -449,7 +449,7 @@
           <a:lstStyle xmlns:a="http://schemas.openxmlformats.org/drawingml/2006/main"/>
           <a:p xmlns:a="http://schemas.openxmlformats.org/drawingml/2006/main">
             <a:r>
-              <a:t>Team Console. Track: AI in any startup. A prototype for evidence-based recall drills. The demonstrated records are synthetic. Event: https://hackindia.org/2026/ai-first-startup-hackathon-build-a-startup-using-ai-only . Team repository destination: https://github.com/HackIndiaXYZ/ai-first-startup-hackathon-build-a-startup-using-ai-only-console . This deck does not claim organizer approval or eligibility.</a:t>
+              <a:t>Team Console. Track: AI in any startup. RecallScope connects ingredient lots, production batches and recorded customer deliveries. The displayed bakery dataset is fictional sample data. Official team source repository: https://github.com/HackIndiaXYZ/ai-first-startup-hackathon-build-a-startup-using-ai-only-console .</a:t>
             </a:r>
           </a:p>
         </p:txBody>
@@ -659,7 +659,7 @@
           <a:lstStyle xmlns:a="http://schemas.openxmlformats.org/drawingml/2006/main"/>
           <a:p xmlns:a="http://schemas.openxmlformats.org/drawingml/2006/main">
             <a:r>
-              <a:t>Source: verified synthetic demo totals supplied by the RecallScope implementation lead on 12 September 2026. Initial affected scope: 2 batches, 720 delivered packs, 2 customers. After review: 3 batches, 1,080 delivered packs, 3 customers. Packs with unresolved linkage decrease from 720 to 360 because another production sheet remains missing. These are fixture results, not real manufacturer data or customer outcomes. No measured time-saving claim accompanies these figures.</a:t>
+              <a:t>Source: completeSampleWorkspace() and automated domain tests, verified 12 September 2026. Lot FL-260901-A: 4 batches, 1,440 delivered packs, 4 customer destinations, 96 kg ingredient used. Lot FL-260902-B: 1 batch, 360 packs, 1 destination, 24 kg used. Seven source documents support the workspace, including production sheets for batches CK-0904-01 and CK-0904-02. These are pre-authored fictional sample records, separate from live AI extraction. No customer outcomes are claimed.</a:t>
             </a:r>
           </a:p>
         </p:txBody>
@@ -799,7 +799,7 @@
           <a:lstStyle xmlns:a="http://schemas.openxmlformats.org/drawingml/2006/main"/>
           <a:p xmlns:a="http://schemas.openxmlformats.org/drawingml/2006/main">
             <a:r>
-              <a:t>The ₹3,000–10,000 per site per month range is an unvalidated pricing hypothesis supplied for this pitch. There are no claimed paying customers, interviews, pilots, revenue, purchase commitments or customer-validated savings. The proposed entry point is a guided recall drill with a small manufacturer, followed by evaluating whether recurring drills warrant a subscription.</a:t>
+              <a:t>The displayed subscription range is a proposed commercial model, not earned revenue or a validated willingness-to-pay result. Target buyer: the quality or operations lead of a small food manufacturer. The product offer is a traceability workspace and saved evidence reports.</a:t>
             </a:r>
           </a:p>
         </p:txBody>
@@ -869,7 +869,7 @@
           <a:lstStyle xmlns:a="http://schemas.openxmlformats.org/drawingml/2006/main"/>
           <a:p xmlns:a="http://schemas.openxmlformats.org/drawingml/2006/main">
             <a:r>
-              <a:t>This is a proposed validation plan, not completed research. Use permissioned and appropriately handled manufacturer records. Establish a human-reviewed expected trace before comparing outputs. Measure completion time without promising any reduction. FDA June 2026 tabletop exercise update says proactive supply-chain coordination drove the strongest results more than any particular technology: https://www.fda.gov/food/hfp-constituent-updates/fda-releases-report-traceability-readiness-tabletop-exercises-and-updated-faqs . This supports explicitly examining information gaps and handoffs rather than claiming that software alone resolves traceability. Live Fireworks extraction checks have passed on small synthetic text and PDF fixtures. That result does not replace the proposed manufacturer pilot. Public deployment and the final demo video remain pending. The source release belongs to the official Team Console repository: https://github.com/HackIndiaXYZ/ai-first-startup-hackathon-build-a-startup-using-ai-only-console . No exact automated-test count is asserted in this deck.</a:t>
+              <a:t>Observed local verification on 12 September 2026: all 45 domain/provider tests passed, TypeScript type checking passed, production build passed, and API integration passed. Coverage includes complete sample totals and source dependencies, immutable reports, duplicate imports, invalid units and dates, concurrent writes, session isolation and provider configuration. Live Fireworks fixture results are documented separately in docs/LIVE-AI-VALIDATION.md. These engineering results do not claim real manufacturer outcomes or certification.</a:t>
             </a:r>
           </a:p>
         </p:txBody>
@@ -939,7 +939,7 @@
           <a:lstStyle xmlns:a="http://schemas.openxmlformats.org/drawingml/2006/main"/>
           <a:p xmlns:a="http://schemas.openxmlformats.org/drawingml/2006/main">
             <a:r>
-              <a:t>Ask: an introduction to one small food manufacturer willing to participate in a permissioned, supervised recall-drill pilot. Team Console. Track: AI in any startup. Contact through the project team. Do not present this request as an agreed partnership. Competition source: https://hackindia.org/2026/ai-first-startup-hackathon-build-a-startup-using-ai-only .</a:t>
+              <a:t>Product walkthrough close: select an ingredient lot, follow the connected production batches and deliveries, inspect the underlying documents, and create a fixed report. Team Console. Track: AI in any startup. Source repository: https://github.com/HackIndiaXYZ/ai-first-startup-hackathon-build-a-startup-using-ai-only-console .</a:t>
             </a:r>
           </a:p>
         </p:txBody>
@@ -1007,7 +1007,7 @@
   </p:cSld>
   <p:clrMap bg1="lt1" tx1="dk1" bg2="lt2" tx2="dk2" accent1="accent1" accent2="accent2" accent3="accent3" accent4="accent4" accent5="accent5" accent6="accent6" hlink="hlink" folHlink="folHlink"/>
   <p:sldLayoutIdLst>
-    <p:sldLayoutId xmlns:r="http://schemas.openxmlformats.org/officeDocument/2006/relationships" id="2147483649" r:id="R6f0d58c904774fda"/>
+    <p:sldLayoutId xmlns:r="http://schemas.openxmlformats.org/officeDocument/2006/relationships" id="2147483649" r:id="R203f7e56ea094597"/>
   </p:sldLayoutIdLst>
   <p:txStyles>
     <p:titleStyle>
@@ -1664,7 +1664,7 @@
                 <a:ea typeface="Arial"/>
                 <a:cs typeface="Arial"/>
               </a:rPr>
-              <a:t>Recall drills with evidence</a:t>
+              <a:t>Ingredient-to-customer traceability</a:t>
             </a:r>
           </a:p>
         </p:txBody>
@@ -2524,7 +2524,7 @@
                 <a:ea typeface="Arial"/>
                 <a:cs typeface="Arial"/>
               </a:rPr>
-              <a:t>A drill built around source records</a:t>
+              <a:t>A trace built around source records</a:t>
             </a:r>
           </a:p>
         </p:txBody>
@@ -2582,7 +2582,7 @@
                 <a:ea typeface="Arial"/>
                 <a:cs typeface="Arial"/>
               </a:rPr>
-              <a:t>One flow from uploaded records to a reviewable report</a:t>
+              <a:t>One workspace from source documents to a saved report</a:t>
             </a:r>
           </a:p>
         </p:txBody>
@@ -3162,7 +3162,7 @@
                 <a:ea typeface="Arial"/>
                 <a:cs typeface="Arial"/>
               </a:rPr>
-              <a:t>Review the scope</a:t>
+              <a:t>Explore evidence</a:t>
             </a:r>
           </a:p>
         </p:txBody>
@@ -3220,7 +3220,7 @@
                 <a:ea typeface="Arial"/>
                 <a:cs typeface="Arial"/>
               </a:rPr>
-              <a:t>Inspect source evidence and resolve uncertain links.</a:t>
+              <a:t>Open the source behind each connected batch and delivery.</a:t>
             </a:r>
           </a:p>
         </p:txBody>
@@ -3336,7 +3336,7 @@
                 <a:ea typeface="Arial"/>
                 <a:cs typeface="Arial"/>
               </a:rPr>
-              <a:t>Export the drill</a:t>
+              <a:t>Save the report</a:t>
             </a:r>
           </a:p>
         </p:txBody>
@@ -3394,14 +3394,14 @@
                 <a:ea typeface="Arial"/>
                 <a:cs typeface="Arial"/>
               </a:rPr>
-              <a:t>Share affected deliveries and outstanding gaps.</a:t>
+              <a:t>Preserve delivered quantities and their supporting records.</a:t>
             </a:r>
           </a:p>
         </p:txBody>
       </p:sp>
       <p:cxnSp>
         <p:nvCxnSpPr>
-          <p:cNvPr id="75" name=""/>
+          <p:cNvPr id="94" name=""/>
           <p:cNvCxnSpPr>
             <a:stCxn xmlns:a="http://schemas.openxmlformats.org/drawingml/2006/main" id="6" idx="3"/>
             <a:endCxn xmlns:a="http://schemas.openxmlformats.org/drawingml/2006/main" id="9" idx="1"/>
@@ -3426,7 +3426,7 @@
       </p:cxnSp>
       <p:cxnSp>
         <p:nvCxnSpPr>
-          <p:cNvPr id="76" name=""/>
+          <p:cNvPr id="95" name=""/>
           <p:cNvCxnSpPr>
             <a:stCxn xmlns:a="http://schemas.openxmlformats.org/drawingml/2006/main" id="9" idx="3"/>
             <a:endCxn xmlns:a="http://schemas.openxmlformats.org/drawingml/2006/main" id="12" idx="1"/>
@@ -3451,7 +3451,7 @@
       </p:cxnSp>
       <p:cxnSp>
         <p:nvCxnSpPr>
-          <p:cNvPr id="77" name=""/>
+          <p:cNvPr id="96" name=""/>
           <p:cNvCxnSpPr>
             <a:stCxn xmlns:a="http://schemas.openxmlformats.org/drawingml/2006/main" id="12" idx="3"/>
             <a:endCxn xmlns:a="http://schemas.openxmlformats.org/drawingml/2006/main" id="15" idx="1"/>
@@ -3614,7 +3614,7 @@
                 <a:ea typeface="Arial"/>
                 <a:cs typeface="Arial"/>
               </a:rPr>
-              <a:t>One review changes the drill scope</a:t>
+              <a:t>A complete ingredient-to-customer trace</a:t>
             </a:r>
           </a:p>
         </p:txBody>
@@ -3672,7 +3672,7 @@
                 <a:ea typeface="Arial"/>
                 <a:cs typeface="Arial"/>
               </a:rPr>
-              <a:t>Synthetic demo: an operator resolves one ambiguous batch code</a:t>
+              <a:t>Sample workspace · Fieldwork Bakery · two ingredient lots</a:t>
             </a:r>
           </a:p>
         </p:txBody>
@@ -3861,7 +3861,7 @@
                           <a:ea typeface="Arial"/>
                           <a:cs typeface="Arial"/>
                         </a:rPr>
-                        <a:t>Initial trace</a:t>
+                        <a:t>FL-260901-A</a:t>
                       </a:r>
                     </a:p>
                   </a:txBody>
@@ -3890,7 +3890,7 @@
                           <a:ea typeface="Arial"/>
                           <a:cs typeface="Arial"/>
                         </a:rPr>
-                        <a:t>After review</a:t>
+                        <a:t>FL-260902-B</a:t>
                       </a:r>
                     </a:p>
                   </a:txBody>
@@ -3921,7 +3921,7 @@
                           <a:ea typeface="Arial"/>
                           <a:cs typeface="Arial"/>
                         </a:rPr>
-                        <a:t>Affected production batches</a:t>
+                        <a:t>Production batches</a:t>
                       </a:r>
                     </a:p>
                   </a:txBody>
@@ -3950,7 +3950,7 @@
                           <a:ea typeface="Arial"/>
                           <a:cs typeface="Arial"/>
                         </a:rPr>
-                        <a:t>2</a:t>
+                        <a:t>4</a:t>
                       </a:r>
                     </a:p>
                   </a:txBody>
@@ -3979,7 +3979,7 @@
                           <a:ea typeface="Arial"/>
                           <a:cs typeface="Arial"/>
                         </a:rPr>
-                        <a:t>3</a:t>
+                        <a:t>1</a:t>
                       </a:r>
                     </a:p>
                   </a:txBody>
@@ -4010,7 +4010,7 @@
                           <a:ea typeface="Arial"/>
                           <a:cs typeface="Arial"/>
                         </a:rPr>
-                        <a:t>Affected delivered packs</a:t>
+                        <a:t>Delivered packs</a:t>
                       </a:r>
                     </a:p>
                   </a:txBody>
@@ -4039,7 +4039,7 @@
                           <a:ea typeface="Arial"/>
                           <a:cs typeface="Arial"/>
                         </a:rPr>
-                        <a:t>720</a:t>
+                        <a:t>1,440</a:t>
                       </a:r>
                     </a:p>
                   </a:txBody>
@@ -4068,7 +4068,7 @@
                           <a:ea typeface="Arial"/>
                           <a:cs typeface="Arial"/>
                         </a:rPr>
-                        <a:t>1,080</a:t>
+                        <a:t>360</a:t>
                       </a:r>
                     </a:p>
                   </a:txBody>
@@ -4099,7 +4099,7 @@
                           <a:ea typeface="Arial"/>
                           <a:cs typeface="Arial"/>
                         </a:rPr>
-                        <a:t>Affected customers</a:t>
+                        <a:t>Customer destinations</a:t>
                       </a:r>
                     </a:p>
                   </a:txBody>
@@ -4128,7 +4128,7 @@
                           <a:ea typeface="Arial"/>
                           <a:cs typeface="Arial"/>
                         </a:rPr>
-                        <a:t>2</a:t>
+                        <a:t>4</a:t>
                       </a:r>
                     </a:p>
                   </a:txBody>
@@ -4157,7 +4157,7 @@
                           <a:ea typeface="Arial"/>
                           <a:cs typeface="Arial"/>
                         </a:rPr>
-                        <a:t>3</a:t>
+                        <a:t>1</a:t>
                       </a:r>
                     </a:p>
                   </a:txBody>
@@ -4182,19 +4182,19 @@
                       <a:r>
                         <a:rPr sz="2175" b="0">
                           <a:solidFill>
-                            <a:srgbClr val="B87519"/>
+                            <a:srgbClr val="163541"/>
                           </a:solidFill>
                           <a:latin typeface="Arial"/>
                           <a:ea typeface="Arial"/>
                           <a:cs typeface="Arial"/>
                         </a:rPr>
-                        <a:t>Packs with unresolved linkage</a:t>
+                        <a:t>Ingredient used (kg)</a:t>
                       </a:r>
                     </a:p>
                   </a:txBody>
                   <a:tcPr marL="91440" marR="91440" marT="45720" marB="45720">
                     <a:solidFill>
-                      <a:srgbClr val="FFF2DC"/>
+                      <a:srgbClr val="FFFFFF"/>
                     </a:solidFill>
                   </a:tcPr>
                 </a:tc>
@@ -4211,19 +4211,19 @@
                       <a:r>
                         <a:rPr sz="2175" b="1">
                           <a:solidFill>
-                            <a:srgbClr val="B87519"/>
+                            <a:srgbClr val="163541"/>
                           </a:solidFill>
                           <a:latin typeface="Arial"/>
                           <a:ea typeface="Arial"/>
                           <a:cs typeface="Arial"/>
                         </a:rPr>
-                        <a:t>720</a:t>
+                        <a:t>96</a:t>
                       </a:r>
                     </a:p>
                   </a:txBody>
                   <a:tcPr marL="91440" marR="91440" marT="45720" marB="45720">
                     <a:solidFill>
-                      <a:srgbClr val="FFF2DC"/>
+                      <a:srgbClr val="FFFFFF"/>
                     </a:solidFill>
                   </a:tcPr>
                 </a:tc>
@@ -4240,19 +4240,19 @@
                       <a:r>
                         <a:rPr sz="2175" b="1">
                           <a:solidFill>
-                            <a:srgbClr val="B87519"/>
+                            <a:srgbClr val="163541"/>
                           </a:solidFill>
                           <a:latin typeface="Arial"/>
                           <a:ea typeface="Arial"/>
                           <a:cs typeface="Arial"/>
                         </a:rPr>
-                        <a:t>360</a:t>
+                        <a:t>24</a:t>
                       </a:r>
                     </a:p>
                   </a:txBody>
                   <a:tcPr marL="91440" marR="91440" marT="45720" marB="45720">
                     <a:solidFill>
-                      <a:srgbClr val="FFF2DC"/>
+                      <a:srgbClr val="FFFFFF"/>
                     </a:solidFill>
                   </a:tcPr>
                 </a:tc>
@@ -4308,13 +4308,13 @@
             <a:r>
               <a:rPr sz="2025" b="1">
                 <a:solidFill>
-                  <a:srgbClr val="B87519"/>
-                </a:solidFill>
-                <a:latin typeface="Arial"/>
-                <a:ea typeface="Arial"/>
-                <a:cs typeface="Arial"/>
-              </a:rPr>
-              <a:t>360 packs remain unresolved because another production sheet is missing.</a:t>
+                  <a:srgbClr val="007D82"/>
+                </a:solidFill>
+                <a:latin typeface="Arial"/>
+                <a:ea typeface="Arial"/>
+                <a:cs typeface="Arial"/>
+              </a:rPr>
+              <a:t>Every displayed delivery connects to its supporting source record.</a:t>
             </a:r>
           </a:p>
         </p:txBody>
@@ -4459,7 +4459,7 @@
                 <a:ea typeface="Arial"/>
                 <a:cs typeface="Arial"/>
               </a:rPr>
-              <a:t>AI proposes records. The operator reviews. Code calculates.</a:t>
+              <a:t>AI extracts document fields for approval and deterministic tracing.</a:t>
             </a:r>
           </a:p>
         </p:txBody>
@@ -4757,7 +4757,7 @@
                 <a:ea typeface="Arial"/>
                 <a:cs typeface="Arial"/>
               </a:rPr>
-              <a:t>Operator reviews</a:t>
+              <a:t>Approve records</a:t>
             </a:r>
           </a:p>
         </p:txBody>
@@ -4815,7 +4815,7 @@
                 <a:ea typeface="Arial"/>
                 <a:cs typeface="Arial"/>
               </a:rPr>
-              <a:t>Checks evidence and accepts or corrects links.</a:t>
+              <a:t>Compare source evidence and accept the records into the workspace.</a:t>
             </a:r>
           </a:p>
         </p:txBody>
@@ -4942,7 +4942,7 @@
       </p:sp>
       <p:cxnSp>
         <p:nvCxnSpPr>
-          <p:cNvPr id="48" name=""/>
+          <p:cNvPr id="60" name=""/>
           <p:cNvCxnSpPr>
             <a:stCxn xmlns:a="http://schemas.openxmlformats.org/drawingml/2006/main" id="5" idx="3"/>
             <a:endCxn xmlns:a="http://schemas.openxmlformats.org/drawingml/2006/main" id="7" idx="1"/>
@@ -4967,7 +4967,7 @@
       </p:cxnSp>
       <p:cxnSp>
         <p:nvCxnSpPr>
-          <p:cNvPr id="49" name=""/>
+          <p:cNvPr id="61" name=""/>
           <p:cNvCxnSpPr>
             <a:stCxn xmlns:a="http://schemas.openxmlformats.org/drawingml/2006/main" id="7" idx="3"/>
             <a:endCxn xmlns:a="http://schemas.openxmlformats.org/drawingml/2006/main" id="9" idx="1"/>
@@ -5043,8 +5043,28 @@
                 <a:ea typeface="Arial"/>
                 <a:cs typeface="Arial"/>
               </a:rPr>
-              <a:t>Live Fireworks checks on synthetic text and PDF: 3 records each.
-Reviewed PDF import: 180 confirmed packs, 0 unresolved.</a:t>
+              <a:t>Live Fireworks extraction on sample text and PDF: 3 records each.</a:t>
+            </a:r>
+            <a:br>
+              <a:rPr sz="2025" b="1">
+                <a:solidFill>
+                  <a:srgbClr val="006D6D"/>
+                </a:solidFill>
+                <a:latin typeface="Arial"/>
+                <a:ea typeface="Arial"/>
+                <a:cs typeface="Arial"/>
+              </a:rPr>
+            </a:br>
+            <a:r>
+              <a:rPr sz="2025" b="1">
+                <a:solidFill>
+                  <a:srgbClr val="006D6D"/>
+                </a:solidFill>
+                <a:latin typeface="Arial"/>
+                <a:ea typeface="Arial"/>
+                <a:cs typeface="Arial"/>
+              </a:rPr>
+              <a:t>Approved PDF import: 180 delivered packs with source evidence.</a:t>
             </a:r>
           </a:p>
         </p:txBody>
@@ -5131,7 +5151,7 @@
                 <a:ea typeface="Arial"/>
                 <a:cs typeface="Arial"/>
               </a:rPr>
-              <a:t>A focused buyer and pricing hypothesis</a:t>
+              <a:t>A focused buyer and subscription model</a:t>
             </a:r>
           </a:p>
         </p:txBody>
@@ -5421,7 +5441,7 @@
                 <a:ea typeface="Arial"/>
                 <a:cs typeface="Arial"/>
               </a:rPr>
-              <a:t>Proposed range to test with buyers</a:t>
+              <a:t>Proposed subscription range</a:t>
             </a:r>
           </a:p>
         </p:txBody>
@@ -5595,7 +5615,7 @@
                 <a:ea typeface="Arial"/>
                 <a:cs typeface="Arial"/>
               </a:rPr>
-              <a:t>First offer</a:t>
+              <a:t>Workspace includes</a:t>
             </a:r>
           </a:p>
         </p:txBody>
@@ -5653,7 +5673,7 @@
                 <a:ea typeface="Arial"/>
                 <a:cs typeface="Arial"/>
               </a:rPr>
-              <a:t>A guided recall drill with an evidence report</a:t>
+              <a:t>Lot tracing and saved evidence reports</a:t>
             </a:r>
           </a:p>
         </p:txBody>
@@ -5740,7 +5760,7 @@
                 <a:ea typeface="Arial"/>
                 <a:cs typeface="Arial"/>
               </a:rPr>
-              <a:t>Pilot validation</a:t>
+              <a:t>Evidence and reliability</a:t>
             </a:r>
           </a:p>
         </p:txBody>
@@ -5798,7 +5818,7 @@
                 <a:ea typeface="Arial"/>
                 <a:cs typeface="Arial"/>
               </a:rPr>
-              <a:t>Next: compare manual and RecallScope drills on manufacturer records</a:t>
+              <a:t>The recorded workflow is supported by 45 automated checks</a:t>
             </a:r>
           </a:p>
         </p:txBody>
@@ -5957,7 +5977,7 @@
                           <a:ea typeface="Arial"/>
                           <a:cs typeface="Arial"/>
                         </a:rPr>
-                        <a:t>Question</a:t>
+                        <a:t>Capability</a:t>
                       </a:r>
                     </a:p>
                   </a:txBody>
@@ -5986,7 +6006,7 @@
                           <a:ea typeface="Arial"/>
                           <a:cs typeface="Arial"/>
                         </a:rPr>
-                        <a:t>What we measure</a:t>
+                        <a:t>Verified behavior</a:t>
                       </a:r>
                     </a:p>
                   </a:txBody>
@@ -6017,7 +6037,7 @@
                           <a:ea typeface="Arial"/>
                           <a:cs typeface="Arial"/>
                         </a:rPr>
-                        <a:t>Does the scope match the records?</a:t>
+                        <a:t>Recorded scope</a:t>
                       </a:r>
                     </a:p>
                   </a:txBody>
@@ -6046,7 +6066,7 @@
                           <a:ea typeface="Arial"/>
                           <a:cs typeface="Arial"/>
                         </a:rPr>
-                        <a:t>Affected batch and delivery coverage</a:t>
+                        <a:t>Deterministic batch and pack totals</a:t>
                       </a:r>
                     </a:p>
                   </a:txBody>
@@ -6077,7 +6097,7 @@
                           <a:ea typeface="Arial"/>
                           <a:cs typeface="Arial"/>
                         </a:rPr>
-                        <a:t>Does the report expose gaps?</a:t>
+                        <a:t>Original documents</a:t>
                       </a:r>
                     </a:p>
                   </a:txBody>
@@ -6106,7 +6126,7 @@
                           <a:ea typeface="Arial"/>
                           <a:cs typeface="Arial"/>
                         </a:rPr>
-                        <a:t>Missing and ambiguous links surfaced</a:t>
+                        <a:t>Source text and retained files</a:t>
                       </a:r>
                     </a:p>
                   </a:txBody>
@@ -6137,7 +6157,7 @@
                           <a:ea typeface="Arial"/>
                           <a:cs typeface="Arial"/>
                         </a:rPr>
-                        <a:t>How much review does it need?</a:t>
+                        <a:t>Saved reports</a:t>
                       </a:r>
                     </a:p>
                   </a:txBody>
@@ -6166,7 +6186,7 @@
                           <a:ea typeface="Arial"/>
                           <a:cs typeface="Arial"/>
                         </a:rPr>
-                        <a:t>Corrections and operator review effort</a:t>
+                        <a:t>Fixed snapshots with decision history</a:t>
                       </a:r>
                     </a:p>
                   </a:txBody>
@@ -6197,7 +6217,7 @@
                           <a:ea typeface="Arial"/>
                           <a:cs typeface="Arial"/>
                         </a:rPr>
-                        <a:t>Does the workflow help the team?</a:t>
+                        <a:t>Session and import controls</a:t>
                       </a:r>
                     </a:p>
                   </a:txBody>
@@ -6226,7 +6246,7 @@
                           <a:ea typeface="Arial"/>
                           <a:cs typeface="Arial"/>
                         </a:rPr>
-                        <a:t>Completion time and willingness to pay</a:t>
+                        <a:t>Isolation and validation checks</a:t>
                       </a:r>
                     </a:p>
                   </a:txBody>
@@ -6294,7 +6314,7 @@
                 <a:ea typeface="Arial"/>
                 <a:cs typeface="Arial"/>
               </a:rPr>
-              <a:t>Manufacturer pilots, public deployment and the final video remain pending.</a:t>
+              <a:t>Verified locally across the application, API and saved reports.</a:t>
             </a:r>
           </a:p>
         </p:txBody>
@@ -6381,7 +6401,7 @@
                 <a:ea typeface="Arial"/>
                 <a:cs typeface="Arial"/>
               </a:rPr>
-              <a:t>Seeking one pilot manufacturer</a:t>
+              <a:t>RecallScope</a:t>
             </a:r>
           </a:p>
         </p:txBody>
@@ -6555,7 +6575,7 @@
                 <a:ea typeface="Arial"/>
                 <a:cs typeface="Arial"/>
               </a:rPr>
-              <a:t>One quality lead.</a:t>
+              <a:t>From an ingredient lot</a:t>
             </a:r>
           </a:p>
           <a:p xmlns:a="http://schemas.openxmlformats.org/drawingml/2006/main">
@@ -6579,7 +6599,7 @@
                 <a:ea typeface="Arial"/>
                 <a:cs typeface="Arial"/>
               </a:rPr>
-              <a:t>One permissioned dataset.</a:t>
+              <a:t>to every recorded delivery.</a:t>
             </a:r>
           </a:p>
         </p:txBody>
@@ -6637,7 +6657,7 @@
                 <a:ea typeface="Arial"/>
                 <a:cs typeface="Arial"/>
               </a:rPr>
-              <a:t>We will run a recall drill together and compare the report with your team’s expected trace.</a:t>
+              <a:t>Select a lot, follow its production batches and open the source behind each customer delivery.</a:t>
             </a:r>
           </a:p>
         </p:txBody>
@@ -6695,7 +6715,7 @@
                 <a:ea typeface="Arial"/>
                 <a:cs typeface="Arial"/>
               </a:rPr>
-              <a:t>The goal: find what the records prove and what still needs review.</a:t>
+              <a:t>Team Console · AI in any startup</a:t>
             </a:r>
           </a:p>
         </p:txBody>

</xml_diff>

<commit_message>
Publish live app links and finalize submission materials
</commit_message>
<xml_diff>
--- a/docs/RecallScope-Pitch.pptx
+++ b/docs/RecallScope-Pitch.pptx
@@ -2,20 +2,20 @@
 <file path=ppt/presentation.xml><?xml version="1.0" encoding="utf-8"?>
 <p:presentation xmlns:p="http://schemas.openxmlformats.org/presentationml/2006/main">
   <p:sldMasterIdLst>
-    <p:sldMasterId xmlns:r="http://schemas.openxmlformats.org/officeDocument/2006/relationships" id="2147483648" r:id="R53e763b218b94bc4"/>
+    <p:sldMasterId xmlns:r="http://schemas.openxmlformats.org/officeDocument/2006/relationships" id="2147483648" r:id="R124c4dbfd6cd4e6a"/>
   </p:sldMasterIdLst>
   <p:notesMasterIdLst>
-    <p:notesMasterId xmlns:r="http://schemas.openxmlformats.org/officeDocument/2006/relationships" r:id="Re7a0f3d9085c4ffd"/>
+    <p:notesMasterId xmlns:r="http://schemas.openxmlformats.org/officeDocument/2006/relationships" r:id="Ra3b6320366de4815"/>
   </p:notesMasterIdLst>
   <p:sldIdLst>
-    <p:sldId xmlns:r="http://schemas.openxmlformats.org/officeDocument/2006/relationships" id="256" r:id="R11f4eef862484158"/>
-    <p:sldId xmlns:r="http://schemas.openxmlformats.org/officeDocument/2006/relationships" id="257" r:id="R1f990c554b1942ca"/>
-    <p:sldId xmlns:r="http://schemas.openxmlformats.org/officeDocument/2006/relationships" id="258" r:id="R3a61c693378d4ccd"/>
-    <p:sldId xmlns:r="http://schemas.openxmlformats.org/officeDocument/2006/relationships" id="259" r:id="R542d0c98bb3d47b8"/>
-    <p:sldId xmlns:r="http://schemas.openxmlformats.org/officeDocument/2006/relationships" id="260" r:id="Re6b83f22c5c640d6"/>
-    <p:sldId xmlns:r="http://schemas.openxmlformats.org/officeDocument/2006/relationships" id="261" r:id="R10f0400e01754e6b"/>
-    <p:sldId xmlns:r="http://schemas.openxmlformats.org/officeDocument/2006/relationships" id="262" r:id="R741465ab0cfc438c"/>
-    <p:sldId xmlns:r="http://schemas.openxmlformats.org/officeDocument/2006/relationships" id="263" r:id="R230c1791f7024c4d"/>
+    <p:sldId xmlns:r="http://schemas.openxmlformats.org/officeDocument/2006/relationships" id="256" r:id="R4759f44b04e74632"/>
+    <p:sldId xmlns:r="http://schemas.openxmlformats.org/officeDocument/2006/relationships" id="257" r:id="R27093f2b629a4b9e"/>
+    <p:sldId xmlns:r="http://schemas.openxmlformats.org/officeDocument/2006/relationships" id="258" r:id="R496e03dcd5ea48be"/>
+    <p:sldId xmlns:r="http://schemas.openxmlformats.org/officeDocument/2006/relationships" id="259" r:id="Re68260eeb7454c99"/>
+    <p:sldId xmlns:r="http://schemas.openxmlformats.org/officeDocument/2006/relationships" id="260" r:id="R9f3eb2121a1b4dd0"/>
+    <p:sldId xmlns:r="http://schemas.openxmlformats.org/officeDocument/2006/relationships" id="261" r:id="R573aee2736194e9e"/>
+    <p:sldId xmlns:r="http://schemas.openxmlformats.org/officeDocument/2006/relationships" id="262" r:id="R8bd0b0ab0bde4e67"/>
+    <p:sldId xmlns:r="http://schemas.openxmlformats.org/officeDocument/2006/relationships" id="263" r:id="R94e4a74ab8184e73"/>
   </p:sldIdLst>
   <p:sldSz cx="12192000" cy="6858000"/>
   <p:notesSz cx="6858000" cy="9144000"/>
@@ -869,7 +869,7 @@
           <a:lstStyle xmlns:a="http://schemas.openxmlformats.org/drawingml/2006/main"/>
           <a:p xmlns:a="http://schemas.openxmlformats.org/drawingml/2006/main">
             <a:r>
-              <a:t>Observed local verification on 12 September 2026: all 45 domain/provider tests passed, TypeScript type checking passed, production build passed, and API integration passed. Coverage includes complete sample totals and source dependencies, immutable reports, duplicate imports, invalid units and dates, concurrent writes, session isolation and provider configuration. Live Fireworks fixture results are documented separately in docs/LIVE-AI-VALIDATION.md. These engineering results do not claim real manufacturer outcomes or certification.</a:t>
+              <a:t>Observed local verification on 12 September 2026: all 47 domain/provider/SQL tests passed, TypeScript type checking passed, production build passed, and API integration passed. Coverage includes complete sample totals and source dependencies, immutable reports, duplicate imports, invalid units and dates, concurrent writes, session isolation and provider configuration. Live Fireworks fixture results are documented separately in docs/LIVE-AI-VALIDATION.md. These engineering results do not claim real manufacturer outcomes or certification. The public application is deployed at https://recallscope.console3096.chatgpt.site with a server-side Fireworks secret and an atomic daily AI request allowance. Sites reported successful deployment on 12 September 2026.</a:t>
             </a:r>
           </a:p>
         </p:txBody>
@@ -939,7 +939,7 @@
           <a:lstStyle xmlns:a="http://schemas.openxmlformats.org/drawingml/2006/main"/>
           <a:p xmlns:a="http://schemas.openxmlformats.org/drawingml/2006/main">
             <a:r>
-              <a:t>Product walkthrough close: select an ingredient lot, follow the connected production batches and deliveries, inspect the underlying documents, and create a fixed report. Team Console. Track: AI in any startup. Source repository: https://github.com/HackIndiaXYZ/ai-first-startup-hackathon-build-a-startup-using-ai-only-console .</a:t>
+              <a:t>Product walkthrough close: select an ingredient lot, follow the connected production batches and deliveries, inspect the underlying documents, and create a fixed report. Team Console. Track: AI in any startup. Source repository: https://github.com/HackIndiaXYZ/ai-first-startup-hackathon-build-a-startup-using-ai-only-console . Public application: https://recallscope.console3096.chatgpt.site .</a:t>
             </a:r>
           </a:p>
         </p:txBody>
@@ -1007,7 +1007,7 @@
   </p:cSld>
   <p:clrMap bg1="lt1" tx1="dk1" bg2="lt2" tx2="dk2" accent1="accent1" accent2="accent2" accent3="accent3" accent4="accent4" accent5="accent5" accent6="accent6" hlink="hlink" folHlink="folHlink"/>
   <p:sldLayoutIdLst>
-    <p:sldLayoutId xmlns:r="http://schemas.openxmlformats.org/officeDocument/2006/relationships" id="2147483649" r:id="R203f7e56ea094597"/>
+    <p:sldLayoutId xmlns:r="http://schemas.openxmlformats.org/officeDocument/2006/relationships" id="2147483649" r:id="Rd0e765e98d0a4572"/>
   </p:sldLayoutIdLst>
   <p:txStyles>
     <p:titleStyle>
@@ -3401,7 +3401,7 @@
       </p:sp>
       <p:cxnSp>
         <p:nvCxnSpPr>
-          <p:cNvPr id="94" name=""/>
+          <p:cNvPr id="113" name=""/>
           <p:cNvCxnSpPr>
             <a:stCxn xmlns:a="http://schemas.openxmlformats.org/drawingml/2006/main" id="6" idx="3"/>
             <a:endCxn xmlns:a="http://schemas.openxmlformats.org/drawingml/2006/main" id="9" idx="1"/>
@@ -3426,7 +3426,7 @@
       </p:cxnSp>
       <p:cxnSp>
         <p:nvCxnSpPr>
-          <p:cNvPr id="95" name=""/>
+          <p:cNvPr id="114" name=""/>
           <p:cNvCxnSpPr>
             <a:stCxn xmlns:a="http://schemas.openxmlformats.org/drawingml/2006/main" id="9" idx="3"/>
             <a:endCxn xmlns:a="http://schemas.openxmlformats.org/drawingml/2006/main" id="12" idx="1"/>
@@ -3451,7 +3451,7 @@
       </p:cxnSp>
       <p:cxnSp>
         <p:nvCxnSpPr>
-          <p:cNvPr id="96" name=""/>
+          <p:cNvPr id="115" name=""/>
           <p:cNvCxnSpPr>
             <a:stCxn xmlns:a="http://schemas.openxmlformats.org/drawingml/2006/main" id="12" idx="3"/>
             <a:endCxn xmlns:a="http://schemas.openxmlformats.org/drawingml/2006/main" id="15" idx="1"/>
@@ -4942,7 +4942,7 @@
       </p:sp>
       <p:cxnSp>
         <p:nvCxnSpPr>
-          <p:cNvPr id="60" name=""/>
+          <p:cNvPr id="72" name=""/>
           <p:cNvCxnSpPr>
             <a:stCxn xmlns:a="http://schemas.openxmlformats.org/drawingml/2006/main" id="5" idx="3"/>
             <a:endCxn xmlns:a="http://schemas.openxmlformats.org/drawingml/2006/main" id="7" idx="1"/>
@@ -4967,7 +4967,7 @@
       </p:cxnSp>
       <p:cxnSp>
         <p:nvCxnSpPr>
-          <p:cNvPr id="61" name=""/>
+          <p:cNvPr id="73" name=""/>
           <p:cNvCxnSpPr>
             <a:stCxn xmlns:a="http://schemas.openxmlformats.org/drawingml/2006/main" id="7" idx="3"/>
             <a:endCxn xmlns:a="http://schemas.openxmlformats.org/drawingml/2006/main" id="9" idx="1"/>
@@ -5045,16 +5045,7 @@
               </a:rPr>
               <a:t>Live Fireworks extraction on sample text and PDF: 3 records each.</a:t>
             </a:r>
-            <a:br>
-              <a:rPr sz="2025" b="1">
-                <a:solidFill>
-                  <a:srgbClr val="006D6D"/>
-                </a:solidFill>
-                <a:latin typeface="Arial"/>
-                <a:ea typeface="Arial"/>
-                <a:cs typeface="Arial"/>
-              </a:rPr>
-            </a:br>
+            <a:br/>
             <a:r>
               <a:rPr sz="2025" b="1">
                 <a:solidFill>
@@ -5818,7 +5809,18 @@
                 <a:ea typeface="Arial"/>
                 <a:cs typeface="Arial"/>
               </a:rPr>
-              <a:t>The recorded workflow is supported by 45 automated checks</a:t>
+              <a:t>The recorded workflow is supported by </a:t>
+            </a:r>
+            <a:r>
+              <a:rPr sz="1875" b="0">
+                <a:solidFill>
+                  <a:srgbClr val="58717A"/>
+                </a:solidFill>
+                <a:latin typeface="Arial"/>
+                <a:ea typeface="Arial"/>
+                <a:cs typeface="Arial"/>
+              </a:rPr>
+              <a:t>47 automated checks</a:t>
             </a:r>
           </a:p>
         </p:txBody>
@@ -6715,7 +6717,7 @@
                 <a:ea typeface="Arial"/>
                 <a:cs typeface="Arial"/>
               </a:rPr>
-              <a:t>Team Console · AI in any startup</a:t>
+              <a:t>recallscope.console3096.chatgpt.site</a:t>
             </a:r>
           </a:p>
         </p:txBody>

</xml_diff>